<commit_message>
docs: redesenha identidade visual dos slides
</commit_message>
<xml_diff>
--- a/docs/parte2/slides.pptx
+++ b/docs/parte2/slides.pptx
@@ -4193,7 +4193,7 @@
     <p:bg>
       <p:bgPr>
         <a:solidFill>
-          <a:srgbClr val="FBFBF6"/>
+          <a:srgbClr val="F7F9F0"/>
         </a:solidFill>
         <a:effectLst/>
       </p:bgPr>
@@ -4207,7 +4207,51 @@
       <p:grpSpPr/>
       <p:sp>
         <p:nvSpPr>
-          <p:cNvPr id="2" name="TextBox 1"/>
+          <p:cNvPr id="2" name="Rectangle 1"/>
+          <p:cNvSpPr/>
+          <p:nvPr/>
+        </p:nvSpPr>
+        <p:spPr>
+          <a:xfrm>
+            <a:off x="0" y="0"/>
+            <a:ext cx="12191695" cy="73152"/>
+          </a:xfrm>
+          <a:prstGeom prst="rect">
+            <a:avLst/>
+          </a:prstGeom>
+          <a:solidFill>
+            <a:srgbClr val="1E6B33"/>
+          </a:solidFill>
+          <a:ln>
+            <a:noFill/>
+          </a:ln>
+          <a:effectLst/>
+        </p:spPr>
+        <p:style>
+          <a:lnRef idx="1">
+            <a:schemeClr val="accent1"/>
+          </a:lnRef>
+          <a:fillRef idx="3">
+            <a:schemeClr val="accent1"/>
+          </a:fillRef>
+          <a:effectRef idx="2">
+            <a:schemeClr val="accent1"/>
+          </a:effectRef>
+          <a:fontRef idx="minor">
+            <a:schemeClr val="lt1"/>
+          </a:fontRef>
+        </p:style>
+        <p:txBody>
+          <a:bodyPr rtlCol="0" anchor="ctr"/>
+          <a:lstStyle/>
+          <a:p>
+            <a:pPr algn="ctr"/>
+          </a:p>
+        </p:txBody>
+      </p:sp>
+      <p:sp>
+        <p:nvSpPr>
+          <p:cNvPr id="3" name="TextBox 2"/>
           <p:cNvSpPr txBox="1"/>
           <p:nvPr/>
         </p:nvSpPr>
@@ -4231,7 +4275,7 @@
             <a:r>
               <a:rPr sz="1400" b="1">
                 <a:solidFill>
-                  <a:srgbClr val="1B5E20"/>
+                  <a:srgbClr val="0C3B1F"/>
                 </a:solidFill>
                 <a:latin typeface="Segoe UI"/>
               </a:rPr>
@@ -4242,7 +4286,7 @@
       </p:sp>
       <p:sp>
         <p:nvSpPr>
-          <p:cNvPr id="3" name="TextBox 2"/>
+          <p:cNvPr id="4" name="TextBox 3"/>
           <p:cNvSpPr txBox="1"/>
           <p:nvPr/>
         </p:nvSpPr>
@@ -4266,9 +4310,9 @@
             <a:r>
               <a:rPr sz="5400" b="1">
                 <a:solidFill>
-                  <a:srgbClr val="1B5E20"/>
-                </a:solidFill>
-                <a:latin typeface="Segoe UI"/>
+                  <a:srgbClr val="0C3B1F"/>
+                </a:solidFill>
+                <a:latin typeface="Bahnschrift"/>
               </a:rPr>
               <a:t>CampoConecta</a:t>
             </a:r>
@@ -4277,7 +4321,7 @@
       </p:sp>
       <p:sp>
         <p:nvSpPr>
-          <p:cNvPr id="4" name="TextBox 3"/>
+          <p:cNvPr id="5" name="TextBox 4"/>
           <p:cNvSpPr txBox="1"/>
           <p:nvPr/>
         </p:nvSpPr>
@@ -4301,7 +4345,7 @@
             <a:r>
               <a:rPr sz="2400" b="0">
                 <a:solidFill>
-                  <a:srgbClr val="1F2D33"/>
+                  <a:srgbClr val="0F1B14"/>
                 </a:solidFill>
                 <a:latin typeface="Segoe UI"/>
               </a:rPr>
@@ -4312,7 +4356,7 @@
       </p:sp>
       <p:sp>
         <p:nvSpPr>
-          <p:cNvPr id="5" name="TextBox 4"/>
+          <p:cNvPr id="6" name="TextBox 5"/>
           <p:cNvSpPr txBox="1"/>
           <p:nvPr/>
         </p:nvSpPr>
@@ -4343,7 +4387,7 @@
             <a:r>
               <a:rPr sz="2400" b="1">
                 <a:solidFill>
-                  <a:srgbClr val="1B5E20"/>
+                  <a:srgbClr val="0C3B1F"/>
                 </a:solidFill>
                 <a:latin typeface="Segoe UI"/>
               </a:rPr>
@@ -4352,7 +4396,7 @@
             <a:r>
               <a:rPr sz="2400" b="0">
                 <a:solidFill>
-                  <a:srgbClr val="1F2D33"/>
+                  <a:srgbClr val="0F1B14"/>
                 </a:solidFill>
                 <a:latin typeface="Segoe UI"/>
               </a:rPr>
@@ -4361,7 +4405,7 @@
             <a:r>
               <a:rPr sz="2400" b="1">
                 <a:solidFill>
-                  <a:srgbClr val="1B5E20"/>
+                  <a:srgbClr val="0C3B1F"/>
                 </a:solidFill>
                 <a:latin typeface="Segoe UI"/>
               </a:rPr>
@@ -4370,7 +4414,7 @@
             <a:r>
               <a:rPr sz="2400" b="0">
                 <a:solidFill>
-                  <a:srgbClr val="1F2D33"/>
+                  <a:srgbClr val="0F1B14"/>
                 </a:solidFill>
                 <a:latin typeface="Segoe UI"/>
               </a:rPr>
@@ -4389,7 +4433,7 @@
             <a:r>
               <a:rPr sz="2400" b="1">
                 <a:solidFill>
-                  <a:srgbClr val="1B5E20"/>
+                  <a:srgbClr val="0C3B1F"/>
                 </a:solidFill>
                 <a:latin typeface="Segoe UI"/>
               </a:rPr>
@@ -4398,7 +4442,7 @@
             <a:r>
               <a:rPr sz="2400" b="0">
                 <a:solidFill>
-                  <a:srgbClr val="1F2D33"/>
+                  <a:srgbClr val="0F1B14"/>
                 </a:solidFill>
                 <a:latin typeface="Segoe UI"/>
               </a:rPr>
@@ -4417,7 +4461,7 @@
             <a:r>
               <a:rPr sz="2400" b="1">
                 <a:solidFill>
-                  <a:srgbClr val="1B5E20"/>
+                  <a:srgbClr val="0C3B1F"/>
                 </a:solidFill>
                 <a:latin typeface="Segoe UI"/>
               </a:rPr>
@@ -4426,7 +4470,7 @@
             <a:r>
               <a:rPr sz="2400" b="0">
                 <a:solidFill>
-                  <a:srgbClr val="1F2D33"/>
+                  <a:srgbClr val="0F1B14"/>
                 </a:solidFill>
                 <a:latin typeface="Segoe UI"/>
               </a:rPr>
@@ -4435,7 +4479,7 @@
             <a:r>
               <a:rPr sz="2400" b="1">
                 <a:solidFill>
-                  <a:srgbClr val="1B5E20"/>
+                  <a:srgbClr val="0C3B1F"/>
                 </a:solidFill>
                 <a:latin typeface="Segoe UI"/>
               </a:rPr>
@@ -4444,7 +4488,7 @@
             <a:r>
               <a:rPr sz="2400" b="0">
                 <a:solidFill>
-                  <a:srgbClr val="1F2D33"/>
+                  <a:srgbClr val="0F1B14"/>
                 </a:solidFill>
                 <a:latin typeface="Segoe UI"/>
               </a:rPr>
@@ -4455,7 +4499,7 @@
       </p:sp>
       <p:sp>
         <p:nvSpPr>
-          <p:cNvPr id="6" name="Rounded Rectangle 5"/>
+          <p:cNvPr id="7" name="Rounded Rectangle 6"/>
           <p:cNvSpPr/>
           <p:nvPr/>
         </p:nvSpPr>
@@ -4468,12 +4512,10 @@
             <a:avLst/>
           </a:prstGeom>
           <a:solidFill>
-            <a:srgbClr val="E8F5E9"/>
+            <a:srgbClr val="0C3B1F"/>
           </a:solidFill>
           <a:ln>
-            <a:solidFill>
-              <a:srgbClr val="E8F5E9"/>
-            </a:solidFill>
+            <a:noFill/>
           </a:ln>
           <a:effectLst/>
         </p:spPr>
@@ -4492,19 +4534,63 @@
           </a:fontRef>
         </p:style>
         <p:txBody>
-          <a:bodyPr rtlCol="0" anchor="ctr" wrap="square" lIns="228600" rIns="228600"/>
+          <a:bodyPr rtlCol="0" anchor="ctr" wrap="square" lIns="292608" rIns="228600"/>
           <a:lstStyle/>
           <a:p>
             <a:pPr algn="ctr"/>
             <a:r>
               <a:rPr sz="1800" b="0">
                 <a:solidFill>
-                  <a:srgbClr val="1B5E20"/>
+                  <a:srgbClr val="F2FFE0"/>
                 </a:solidFill>
                 <a:latin typeface="Segoe UI"/>
               </a:rPr>
               <a:t>Nesta etapa entregamos o projeto: serviços, contratos, dados e os fluxos distribuídos.</a:t>
             </a:r>
+          </a:p>
+        </p:txBody>
+      </p:sp>
+      <p:sp>
+        <p:nvSpPr>
+          <p:cNvPr id="8" name="Rectangle 7"/>
+          <p:cNvSpPr/>
+          <p:nvPr/>
+        </p:nvSpPr>
+        <p:spPr>
+          <a:xfrm>
+            <a:off x="685800" y="5532120"/>
+            <a:ext cx="100584" cy="868680"/>
+          </a:xfrm>
+          <a:prstGeom prst="rect">
+            <a:avLst/>
+          </a:prstGeom>
+          <a:solidFill>
+            <a:srgbClr val="A3E635"/>
+          </a:solidFill>
+          <a:ln>
+            <a:noFill/>
+          </a:ln>
+          <a:effectLst/>
+        </p:spPr>
+        <p:style>
+          <a:lnRef idx="1">
+            <a:schemeClr val="accent1"/>
+          </a:lnRef>
+          <a:fillRef idx="3">
+            <a:schemeClr val="accent1"/>
+          </a:fillRef>
+          <a:effectRef idx="2">
+            <a:schemeClr val="accent1"/>
+          </a:effectRef>
+          <a:fontRef idx="minor">
+            <a:schemeClr val="lt1"/>
+          </a:fontRef>
+        </p:style>
+        <p:txBody>
+          <a:bodyPr rtlCol="0" anchor="ctr"/>
+          <a:lstStyle/>
+          <a:p>
+            <a:pPr algn="ctr"/>
           </a:p>
         </p:txBody>
       </p:sp>
@@ -4522,7 +4608,7 @@
     <p:bg>
       <p:bgPr>
         <a:solidFill>
-          <a:srgbClr val="FBFBF6"/>
+          <a:srgbClr val="F7F9F0"/>
         </a:solidFill>
         <a:effectLst/>
       </p:bgPr>
@@ -4536,14 +4622,58 @@
       <p:grpSpPr/>
       <p:sp>
         <p:nvSpPr>
-          <p:cNvPr id="2" name="TextBox 1"/>
+          <p:cNvPr id="2" name="Rectangle 1"/>
+          <p:cNvSpPr/>
+          <p:nvPr/>
+        </p:nvSpPr>
+        <p:spPr>
+          <a:xfrm>
+            <a:off x="0" y="0"/>
+            <a:ext cx="12191695" cy="73152"/>
+          </a:xfrm>
+          <a:prstGeom prst="rect">
+            <a:avLst/>
+          </a:prstGeom>
+          <a:solidFill>
+            <a:srgbClr val="1E6B33"/>
+          </a:solidFill>
+          <a:ln>
+            <a:noFill/>
+          </a:ln>
+          <a:effectLst/>
+        </p:spPr>
+        <p:style>
+          <a:lnRef idx="1">
+            <a:schemeClr val="accent1"/>
+          </a:lnRef>
+          <a:fillRef idx="3">
+            <a:schemeClr val="accent1"/>
+          </a:fillRef>
+          <a:effectRef idx="2">
+            <a:schemeClr val="accent1"/>
+          </a:effectRef>
+          <a:fontRef idx="minor">
+            <a:schemeClr val="lt1"/>
+          </a:fontRef>
+        </p:style>
+        <p:txBody>
+          <a:bodyPr rtlCol="0" anchor="ctr"/>
+          <a:lstStyle/>
+          <a:p>
+            <a:pPr algn="ctr"/>
+          </a:p>
+        </p:txBody>
+      </p:sp>
+      <p:sp>
+        <p:nvSpPr>
+          <p:cNvPr id="3" name="TextBox 2"/>
           <p:cNvSpPr txBox="1"/>
           <p:nvPr/>
         </p:nvSpPr>
         <p:spPr>
           <a:xfrm>
-            <a:off x="685800" y="411480"/>
-            <a:ext cx="10881360" cy="914400"/>
+            <a:off x="685800" y="384048"/>
+            <a:ext cx="10881360" cy="822960"/>
           </a:xfrm>
           <a:prstGeom prst="rect">
             <a:avLst/>
@@ -4558,11 +4688,11 @@
           <a:p>
             <a:pPr algn="l"/>
             <a:r>
-              <a:rPr sz="3600" b="1">
-                <a:solidFill>
-                  <a:srgbClr val="1B5E20"/>
-                </a:solidFill>
-                <a:latin typeface="Segoe UI"/>
+              <a:rPr sz="3800" b="1">
+                <a:solidFill>
+                  <a:srgbClr val="0C3B1F"/>
+                </a:solidFill>
+                <a:latin typeface="Bahnschrift"/>
               </a:rPr>
               <a:t>Onde verificar</a:t>
             </a:r>
@@ -4571,13 +4701,57 @@
       </p:sp>
       <p:sp>
         <p:nvSpPr>
-          <p:cNvPr id="3" name="TextBox 2"/>
+          <p:cNvPr id="4" name="Rounded Rectangle 3"/>
+          <p:cNvSpPr/>
+          <p:nvPr/>
+        </p:nvSpPr>
+        <p:spPr>
+          <a:xfrm>
+            <a:off x="713232" y="1152144"/>
+            <a:ext cx="960120" cy="68580"/>
+          </a:xfrm>
+          <a:prstGeom prst="roundRect">
+            <a:avLst/>
+          </a:prstGeom>
+          <a:solidFill>
+            <a:srgbClr val="A3E635"/>
+          </a:solidFill>
+          <a:ln>
+            <a:noFill/>
+          </a:ln>
+          <a:effectLst/>
+        </p:spPr>
+        <p:style>
+          <a:lnRef idx="1">
+            <a:schemeClr val="accent1"/>
+          </a:lnRef>
+          <a:fillRef idx="3">
+            <a:schemeClr val="accent1"/>
+          </a:fillRef>
+          <a:effectRef idx="2">
+            <a:schemeClr val="accent1"/>
+          </a:effectRef>
+          <a:fontRef idx="minor">
+            <a:schemeClr val="lt1"/>
+          </a:fontRef>
+        </p:style>
+        <p:txBody>
+          <a:bodyPr rtlCol="0" anchor="ctr"/>
+          <a:lstStyle/>
+          <a:p>
+            <a:pPr algn="ctr"/>
+          </a:p>
+        </p:txBody>
+      </p:sp>
+      <p:sp>
+        <p:nvSpPr>
+          <p:cNvPr id="5" name="TextBox 4"/>
           <p:cNvSpPr txBox="1"/>
           <p:nvPr/>
         </p:nvSpPr>
         <p:spPr>
           <a:xfrm>
-            <a:off x="685800" y="1463040"/>
+            <a:off x="685800" y="1481328"/>
             <a:ext cx="10881360" cy="3977639"/>
           </a:xfrm>
           <a:prstGeom prst="rect">
@@ -4602,7 +4776,7 @@
             <a:r>
               <a:rPr sz="2400" b="1">
                 <a:solidFill>
-                  <a:srgbClr val="1B5E20"/>
+                  <a:srgbClr val="0C3B1F"/>
                 </a:solidFill>
                 <a:latin typeface="Segoe UI"/>
               </a:rPr>
@@ -4611,7 +4785,7 @@
             <a:r>
               <a:rPr sz="2400" b="0">
                 <a:solidFill>
-                  <a:srgbClr val="1F2D33"/>
+                  <a:srgbClr val="0F1B14"/>
                 </a:solidFill>
                 <a:latin typeface="Segoe UI"/>
               </a:rPr>
@@ -4620,7 +4794,7 @@
             <a:r>
               <a:rPr sz="2400" b="1">
                 <a:solidFill>
-                  <a:srgbClr val="1B5E20"/>
+                  <a:srgbClr val="0C3B1F"/>
                 </a:solidFill>
                 <a:latin typeface="Segoe UI"/>
               </a:rPr>
@@ -4629,7 +4803,7 @@
             <a:r>
               <a:rPr sz="2400" b="0">
                 <a:solidFill>
-                  <a:srgbClr val="1F2D33"/>
+                  <a:srgbClr val="0F1B14"/>
                 </a:solidFill>
                 <a:latin typeface="Segoe UI"/>
               </a:rPr>
@@ -4648,7 +4822,7 @@
             <a:r>
               <a:rPr sz="2400" b="1">
                 <a:solidFill>
-                  <a:srgbClr val="1B5E20"/>
+                  <a:srgbClr val="0C3B1F"/>
                 </a:solidFill>
                 <a:latin typeface="Segoe UI"/>
               </a:rPr>
@@ -4657,7 +4831,7 @@
             <a:r>
               <a:rPr sz="2400" b="1">
                 <a:solidFill>
-                  <a:srgbClr val="1B5E20"/>
+                  <a:srgbClr val="0C3B1F"/>
                 </a:solidFill>
                 <a:latin typeface="Segoe UI"/>
               </a:rPr>
@@ -4666,7 +4840,7 @@
             <a:r>
               <a:rPr sz="2400" b="0">
                 <a:solidFill>
-                  <a:srgbClr val="1F2D33"/>
+                  <a:srgbClr val="0F1B14"/>
                 </a:solidFill>
                 <a:latin typeface="Segoe UI"/>
               </a:rPr>
@@ -4685,7 +4859,7 @@
             <a:r>
               <a:rPr sz="2400" b="1">
                 <a:solidFill>
-                  <a:srgbClr val="1B5E20"/>
+                  <a:srgbClr val="0C3B1F"/>
                 </a:solidFill>
                 <a:latin typeface="Segoe UI"/>
               </a:rPr>
@@ -4694,7 +4868,7 @@
             <a:r>
               <a:rPr sz="2400" b="1">
                 <a:solidFill>
-                  <a:srgbClr val="1B5E20"/>
+                  <a:srgbClr val="0C3B1F"/>
                 </a:solidFill>
                 <a:latin typeface="Segoe UI"/>
               </a:rPr>
@@ -4703,7 +4877,7 @@
             <a:r>
               <a:rPr sz="2400" b="0">
                 <a:solidFill>
-                  <a:srgbClr val="1F2D33"/>
+                  <a:srgbClr val="0F1B14"/>
                 </a:solidFill>
                 <a:latin typeface="Segoe UI"/>
               </a:rPr>
@@ -4722,7 +4896,7 @@
             <a:r>
               <a:rPr sz="2400" b="1">
                 <a:solidFill>
-                  <a:srgbClr val="1B5E20"/>
+                  <a:srgbClr val="0C3B1F"/>
                 </a:solidFill>
                 <a:latin typeface="Segoe UI"/>
               </a:rPr>
@@ -4731,7 +4905,7 @@
             <a:r>
               <a:rPr sz="2400" b="0">
                 <a:solidFill>
-                  <a:srgbClr val="1F2D33"/>
+                  <a:srgbClr val="0F1B14"/>
                 </a:solidFill>
                 <a:latin typeface="Segoe UI"/>
               </a:rPr>
@@ -4742,7 +4916,7 @@
       </p:sp>
       <p:sp>
         <p:nvSpPr>
-          <p:cNvPr id="4" name="Rounded Rectangle 3"/>
+          <p:cNvPr id="6" name="Rounded Rectangle 5"/>
           <p:cNvSpPr/>
           <p:nvPr/>
         </p:nvSpPr>
@@ -4755,12 +4929,10 @@
             <a:avLst/>
           </a:prstGeom>
           <a:solidFill>
-            <a:srgbClr val="E8F5E9"/>
+            <a:srgbClr val="0C3B1F"/>
           </a:solidFill>
           <a:ln>
-            <a:solidFill>
-              <a:srgbClr val="E8F5E9"/>
-            </a:solidFill>
+            <a:noFill/>
           </a:ln>
           <a:effectLst/>
         </p:spPr>
@@ -4779,19 +4951,63 @@
           </a:fontRef>
         </p:style>
         <p:txBody>
-          <a:bodyPr rtlCol="0" anchor="ctr" wrap="square" lIns="228600" rIns="228600"/>
+          <a:bodyPr rtlCol="0" anchor="ctr" wrap="square" lIns="292608" rIns="228600"/>
           <a:lstStyle/>
           <a:p>
             <a:pPr algn="ctr"/>
             <a:r>
               <a:rPr sz="1800" b="0">
                 <a:solidFill>
-                  <a:srgbClr val="1B5E20"/>
+                  <a:srgbClr val="F2FFE0"/>
                 </a:solidFill>
                 <a:latin typeface="Segoe UI"/>
               </a:rPr>
               <a:t>Tudo é rastreável a partir do README: o critério, o documento e a evidência.</a:t>
             </a:r>
+          </a:p>
+        </p:txBody>
+      </p:sp>
+      <p:sp>
+        <p:nvSpPr>
+          <p:cNvPr id="7" name="Rectangle 6"/>
+          <p:cNvSpPr/>
+          <p:nvPr/>
+        </p:nvSpPr>
+        <p:spPr>
+          <a:xfrm>
+            <a:off x="685800" y="5532120"/>
+            <a:ext cx="100584" cy="868680"/>
+          </a:xfrm>
+          <a:prstGeom prst="rect">
+            <a:avLst/>
+          </a:prstGeom>
+          <a:solidFill>
+            <a:srgbClr val="A3E635"/>
+          </a:solidFill>
+          <a:ln>
+            <a:noFill/>
+          </a:ln>
+          <a:effectLst/>
+        </p:spPr>
+        <p:style>
+          <a:lnRef idx="1">
+            <a:schemeClr val="accent1"/>
+          </a:lnRef>
+          <a:fillRef idx="3">
+            <a:schemeClr val="accent1"/>
+          </a:fillRef>
+          <a:effectRef idx="2">
+            <a:schemeClr val="accent1"/>
+          </a:effectRef>
+          <a:fontRef idx="minor">
+            <a:schemeClr val="lt1"/>
+          </a:fontRef>
+        </p:style>
+        <p:txBody>
+          <a:bodyPr rtlCol="0" anchor="ctr"/>
+          <a:lstStyle/>
+          <a:p>
+            <a:pPr algn="ctr"/>
           </a:p>
         </p:txBody>
       </p:sp>
@@ -4809,7 +5025,7 @@
     <p:bg>
       <p:bgPr>
         <a:solidFill>
-          <a:srgbClr val="FBFBF6"/>
+          <a:srgbClr val="F7F9F0"/>
         </a:solidFill>
         <a:effectLst/>
       </p:bgPr>
@@ -4823,14 +5039,58 @@
       <p:grpSpPr/>
       <p:sp>
         <p:nvSpPr>
-          <p:cNvPr id="2" name="TextBox 1"/>
+          <p:cNvPr id="2" name="Rectangle 1"/>
+          <p:cNvSpPr/>
+          <p:nvPr/>
+        </p:nvSpPr>
+        <p:spPr>
+          <a:xfrm>
+            <a:off x="0" y="0"/>
+            <a:ext cx="12191695" cy="73152"/>
+          </a:xfrm>
+          <a:prstGeom prst="rect">
+            <a:avLst/>
+          </a:prstGeom>
+          <a:solidFill>
+            <a:srgbClr val="1E6B33"/>
+          </a:solidFill>
+          <a:ln>
+            <a:noFill/>
+          </a:ln>
+          <a:effectLst/>
+        </p:spPr>
+        <p:style>
+          <a:lnRef idx="1">
+            <a:schemeClr val="accent1"/>
+          </a:lnRef>
+          <a:fillRef idx="3">
+            <a:schemeClr val="accent1"/>
+          </a:fillRef>
+          <a:effectRef idx="2">
+            <a:schemeClr val="accent1"/>
+          </a:effectRef>
+          <a:fontRef idx="minor">
+            <a:schemeClr val="lt1"/>
+          </a:fontRef>
+        </p:style>
+        <p:txBody>
+          <a:bodyPr rtlCol="0" anchor="ctr"/>
+          <a:lstStyle/>
+          <a:p>
+            <a:pPr algn="ctr"/>
+          </a:p>
+        </p:txBody>
+      </p:sp>
+      <p:sp>
+        <p:nvSpPr>
+          <p:cNvPr id="3" name="TextBox 2"/>
           <p:cNvSpPr txBox="1"/>
           <p:nvPr/>
         </p:nvSpPr>
         <p:spPr>
           <a:xfrm>
-            <a:off x="685800" y="411480"/>
-            <a:ext cx="10881360" cy="914400"/>
+            <a:off x="685800" y="384048"/>
+            <a:ext cx="10881360" cy="822960"/>
           </a:xfrm>
           <a:prstGeom prst="rect">
             <a:avLst/>
@@ -4845,11 +5105,11 @@
           <a:p>
             <a:pPr algn="l"/>
             <a:r>
-              <a:rPr sz="3600" b="1">
-                <a:solidFill>
-                  <a:srgbClr val="1B5E20"/>
-                </a:solidFill>
-                <a:latin typeface="Segoe UI"/>
+              <a:rPr sz="3800" b="1">
+                <a:solidFill>
+                  <a:srgbClr val="0C3B1F"/>
+                </a:solidFill>
+                <a:latin typeface="Bahnschrift"/>
               </a:rPr>
               <a:t>O problema, em uma frase</a:t>
             </a:r>
@@ -4858,13 +5118,57 @@
       </p:sp>
       <p:sp>
         <p:nvSpPr>
-          <p:cNvPr id="3" name="TextBox 2"/>
+          <p:cNvPr id="4" name="Rounded Rectangle 3"/>
+          <p:cNvSpPr/>
+          <p:nvPr/>
+        </p:nvSpPr>
+        <p:spPr>
+          <a:xfrm>
+            <a:off x="713232" y="1152144"/>
+            <a:ext cx="960120" cy="68580"/>
+          </a:xfrm>
+          <a:prstGeom prst="roundRect">
+            <a:avLst/>
+          </a:prstGeom>
+          <a:solidFill>
+            <a:srgbClr val="A3E635"/>
+          </a:solidFill>
+          <a:ln>
+            <a:noFill/>
+          </a:ln>
+          <a:effectLst/>
+        </p:spPr>
+        <p:style>
+          <a:lnRef idx="1">
+            <a:schemeClr val="accent1"/>
+          </a:lnRef>
+          <a:fillRef idx="3">
+            <a:schemeClr val="accent1"/>
+          </a:fillRef>
+          <a:effectRef idx="2">
+            <a:schemeClr val="accent1"/>
+          </a:effectRef>
+          <a:fontRef idx="minor">
+            <a:schemeClr val="lt1"/>
+          </a:fontRef>
+        </p:style>
+        <p:txBody>
+          <a:bodyPr rtlCol="0" anchor="ctr"/>
+          <a:lstStyle/>
+          <a:p>
+            <a:pPr algn="ctr"/>
+          </a:p>
+        </p:txBody>
+      </p:sp>
+      <p:sp>
+        <p:nvSpPr>
+          <p:cNvPr id="5" name="TextBox 4"/>
           <p:cNvSpPr txBox="1"/>
           <p:nvPr/>
         </p:nvSpPr>
         <p:spPr>
           <a:xfrm>
-            <a:off x="685800" y="1463040"/>
+            <a:off x="685800" y="1481328"/>
             <a:ext cx="10881360" cy="3977639"/>
           </a:xfrm>
           <a:prstGeom prst="rect">
@@ -4889,7 +5193,7 @@
             <a:r>
               <a:rPr sz="2600" b="1">
                 <a:solidFill>
-                  <a:srgbClr val="1B5E20"/>
+                  <a:srgbClr val="0C3B1F"/>
                 </a:solidFill>
                 <a:latin typeface="Segoe UI"/>
               </a:rPr>
@@ -4898,7 +5202,7 @@
             <a:r>
               <a:rPr sz="2600" b="0">
                 <a:solidFill>
-                  <a:srgbClr val="1F2D33"/>
+                  <a:srgbClr val="0F1B14"/>
                 </a:solidFill>
                 <a:latin typeface="Segoe UI"/>
               </a:rPr>
@@ -4907,7 +5211,7 @@
             <a:r>
               <a:rPr sz="2600" b="1">
                 <a:solidFill>
-                  <a:srgbClr val="1B5E20"/>
+                  <a:srgbClr val="0C3B1F"/>
                 </a:solidFill>
                 <a:latin typeface="Segoe UI"/>
               </a:rPr>
@@ -4916,7 +5220,7 @@
             <a:r>
               <a:rPr sz="2600" b="0">
                 <a:solidFill>
-                  <a:srgbClr val="1F2D33"/>
+                  <a:srgbClr val="0F1B14"/>
                 </a:solidFill>
                 <a:latin typeface="Segoe UI"/>
               </a:rPr>
@@ -4935,7 +5239,7 @@
             <a:r>
               <a:rPr sz="2600" b="1">
                 <a:solidFill>
-                  <a:srgbClr val="1B5E20"/>
+                  <a:srgbClr val="0C3B1F"/>
                 </a:solidFill>
                 <a:latin typeface="Segoe UI"/>
               </a:rPr>
@@ -4944,7 +5248,7 @@
             <a:r>
               <a:rPr sz="2600" b="0">
                 <a:solidFill>
-                  <a:srgbClr val="1F2D33"/>
+                  <a:srgbClr val="0F1B14"/>
                 </a:solidFill>
                 <a:latin typeface="Segoe UI"/>
               </a:rPr>
@@ -4963,7 +5267,7 @@
             <a:r>
               <a:rPr sz="2600" b="1">
                 <a:solidFill>
-                  <a:srgbClr val="1B5E20"/>
+                  <a:srgbClr val="0C3B1F"/>
                 </a:solidFill>
                 <a:latin typeface="Segoe UI"/>
               </a:rPr>
@@ -4972,7 +5276,7 @@
             <a:r>
               <a:rPr sz="2600" b="0">
                 <a:solidFill>
-                  <a:srgbClr val="1F2D33"/>
+                  <a:srgbClr val="0F1B14"/>
                 </a:solidFill>
                 <a:latin typeface="Segoe UI"/>
               </a:rPr>
@@ -4981,7 +5285,7 @@
             <a:r>
               <a:rPr sz="2600" b="1">
                 <a:solidFill>
-                  <a:srgbClr val="1B5E20"/>
+                  <a:srgbClr val="0C3B1F"/>
                 </a:solidFill>
                 <a:latin typeface="Segoe UI"/>
               </a:rPr>
@@ -4992,7 +5296,7 @@
       </p:sp>
       <p:sp>
         <p:nvSpPr>
-          <p:cNvPr id="4" name="Rounded Rectangle 3"/>
+          <p:cNvPr id="6" name="Rounded Rectangle 5"/>
           <p:cNvSpPr/>
           <p:nvPr/>
         </p:nvSpPr>
@@ -5005,12 +5309,10 @@
             <a:avLst/>
           </a:prstGeom>
           <a:solidFill>
-            <a:srgbClr val="E8F5E9"/>
+            <a:srgbClr val="0C3B1F"/>
           </a:solidFill>
           <a:ln>
-            <a:solidFill>
-              <a:srgbClr val="E8F5E9"/>
-            </a:solidFill>
+            <a:noFill/>
           </a:ln>
           <a:effectLst/>
         </p:spPr>
@@ -5029,19 +5331,63 @@
           </a:fontRef>
         </p:style>
         <p:txBody>
-          <a:bodyPr rtlCol="0" anchor="ctr" wrap="square" lIns="228600" rIns="228600"/>
+          <a:bodyPr rtlCol="0" anchor="ctr" wrap="square" lIns="292608" rIns="228600"/>
           <a:lstStyle/>
           <a:p>
             <a:pPr algn="ctr"/>
             <a:r>
               <a:rPr sz="1800" b="0">
                 <a:solidFill>
-                  <a:srgbClr val="1B5E20"/>
+                  <a:srgbClr val="F2FFE0"/>
                 </a:solidFill>
                 <a:latin typeface="Segoe UI"/>
               </a:rPr>
               <a:t>Existe uma obrigação legal e uma lacuna operacional: é essa lacuna que o sistema resolve.</a:t>
             </a:r>
+          </a:p>
+        </p:txBody>
+      </p:sp>
+      <p:sp>
+        <p:nvSpPr>
+          <p:cNvPr id="7" name="Rectangle 6"/>
+          <p:cNvSpPr/>
+          <p:nvPr/>
+        </p:nvSpPr>
+        <p:spPr>
+          <a:xfrm>
+            <a:off x="685800" y="5532120"/>
+            <a:ext cx="100584" cy="868680"/>
+          </a:xfrm>
+          <a:prstGeom prst="rect">
+            <a:avLst/>
+          </a:prstGeom>
+          <a:solidFill>
+            <a:srgbClr val="A3E635"/>
+          </a:solidFill>
+          <a:ln>
+            <a:noFill/>
+          </a:ln>
+          <a:effectLst/>
+        </p:spPr>
+        <p:style>
+          <a:lnRef idx="1">
+            <a:schemeClr val="accent1"/>
+          </a:lnRef>
+          <a:fillRef idx="3">
+            <a:schemeClr val="accent1"/>
+          </a:fillRef>
+          <a:effectRef idx="2">
+            <a:schemeClr val="accent1"/>
+          </a:effectRef>
+          <a:fontRef idx="minor">
+            <a:schemeClr val="lt1"/>
+          </a:fontRef>
+        </p:style>
+        <p:txBody>
+          <a:bodyPr rtlCol="0" anchor="ctr"/>
+          <a:lstStyle/>
+          <a:p>
+            <a:pPr algn="ctr"/>
           </a:p>
         </p:txBody>
       </p:sp>
@@ -5059,7 +5405,7 @@
     <p:bg>
       <p:bgPr>
         <a:solidFill>
-          <a:srgbClr val="FBFBF6"/>
+          <a:srgbClr val="F7F9F0"/>
         </a:solidFill>
         <a:effectLst/>
       </p:bgPr>
@@ -5073,14 +5419,58 @@
       <p:grpSpPr/>
       <p:sp>
         <p:nvSpPr>
-          <p:cNvPr id="2" name="TextBox 1"/>
+          <p:cNvPr id="2" name="Rectangle 1"/>
+          <p:cNvSpPr/>
+          <p:nvPr/>
+        </p:nvSpPr>
+        <p:spPr>
+          <a:xfrm>
+            <a:off x="0" y="0"/>
+            <a:ext cx="12191695" cy="73152"/>
+          </a:xfrm>
+          <a:prstGeom prst="rect">
+            <a:avLst/>
+          </a:prstGeom>
+          <a:solidFill>
+            <a:srgbClr val="1E6B33"/>
+          </a:solidFill>
+          <a:ln>
+            <a:noFill/>
+          </a:ln>
+          <a:effectLst/>
+        </p:spPr>
+        <p:style>
+          <a:lnRef idx="1">
+            <a:schemeClr val="accent1"/>
+          </a:lnRef>
+          <a:fillRef idx="3">
+            <a:schemeClr val="accent1"/>
+          </a:fillRef>
+          <a:effectRef idx="2">
+            <a:schemeClr val="accent1"/>
+          </a:effectRef>
+          <a:fontRef idx="minor">
+            <a:schemeClr val="lt1"/>
+          </a:fontRef>
+        </p:style>
+        <p:txBody>
+          <a:bodyPr rtlCol="0" anchor="ctr"/>
+          <a:lstStyle/>
+          <a:p>
+            <a:pPr algn="ctr"/>
+          </a:p>
+        </p:txBody>
+      </p:sp>
+      <p:sp>
+        <p:nvSpPr>
+          <p:cNvPr id="3" name="TextBox 2"/>
           <p:cNvSpPr txBox="1"/>
           <p:nvPr/>
         </p:nvSpPr>
         <p:spPr>
           <a:xfrm>
-            <a:off x="685800" y="411480"/>
-            <a:ext cx="10881360" cy="914400"/>
+            <a:off x="685800" y="384048"/>
+            <a:ext cx="10881360" cy="822960"/>
           </a:xfrm>
           <a:prstGeom prst="rect">
             <a:avLst/>
@@ -5095,11 +5485,11 @@
           <a:p>
             <a:pPr algn="l"/>
             <a:r>
-              <a:rPr sz="3600" b="1">
-                <a:solidFill>
-                  <a:srgbClr val="1B5E20"/>
-                </a:solidFill>
-                <a:latin typeface="Segoe UI"/>
+              <a:rPr sz="3800" b="1">
+                <a:solidFill>
+                  <a:srgbClr val="0C3B1F"/>
+                </a:solidFill>
+                <a:latin typeface="Bahnschrift"/>
               </a:rPr>
               <a:t>Arquitetura em uma imagem</a:t>
             </a:r>
@@ -5108,7 +5498,51 @@
       </p:sp>
       <p:sp>
         <p:nvSpPr>
-          <p:cNvPr id="3" name="Rounded Rectangle 2"/>
+          <p:cNvPr id="4" name="Rounded Rectangle 3"/>
+          <p:cNvSpPr/>
+          <p:nvPr/>
+        </p:nvSpPr>
+        <p:spPr>
+          <a:xfrm>
+            <a:off x="713232" y="1152144"/>
+            <a:ext cx="960120" cy="68580"/>
+          </a:xfrm>
+          <a:prstGeom prst="roundRect">
+            <a:avLst/>
+          </a:prstGeom>
+          <a:solidFill>
+            <a:srgbClr val="A3E635"/>
+          </a:solidFill>
+          <a:ln>
+            <a:noFill/>
+          </a:ln>
+          <a:effectLst/>
+        </p:spPr>
+        <p:style>
+          <a:lnRef idx="1">
+            <a:schemeClr val="accent1"/>
+          </a:lnRef>
+          <a:fillRef idx="3">
+            <a:schemeClr val="accent1"/>
+          </a:fillRef>
+          <a:effectRef idx="2">
+            <a:schemeClr val="accent1"/>
+          </a:effectRef>
+          <a:fontRef idx="minor">
+            <a:schemeClr val="lt1"/>
+          </a:fontRef>
+        </p:style>
+        <p:txBody>
+          <a:bodyPr rtlCol="0" anchor="ctr"/>
+          <a:lstStyle/>
+          <a:p>
+            <a:pPr algn="ctr"/>
+          </a:p>
+        </p:txBody>
+      </p:sp>
+      <p:sp>
+        <p:nvSpPr>
+          <p:cNvPr id="5" name="Rounded Rectangle 4"/>
           <p:cNvSpPr/>
           <p:nvPr/>
         </p:nvSpPr>
@@ -5125,7 +5559,7 @@
           </a:solidFill>
           <a:ln w="31750">
             <a:solidFill>
-              <a:srgbClr val="90A4AE"/>
+              <a:srgbClr val="D6DDC9"/>
             </a:solidFill>
           </a:ln>
           <a:effectLst/>
@@ -5152,7 +5586,7 @@
             <a:r>
               <a:rPr sz="1400" b="1">
                 <a:solidFill>
-                  <a:srgbClr val="1F2D33"/>
+                  <a:srgbClr val="0F1B14"/>
                 </a:solidFill>
                 <a:latin typeface="Segoe UI"/>
               </a:rPr>
@@ -5163,7 +5597,7 @@
       </p:sp>
       <p:sp>
         <p:nvSpPr>
-          <p:cNvPr id="4" name="Rounded Rectangle 3"/>
+          <p:cNvPr id="6" name="Rounded Rectangle 5"/>
           <p:cNvSpPr/>
           <p:nvPr/>
         </p:nvSpPr>
@@ -5180,7 +5614,7 @@
           </a:solidFill>
           <a:ln w="31750">
             <a:solidFill>
-              <a:srgbClr val="90A4AE"/>
+              <a:srgbClr val="D6DDC9"/>
             </a:solidFill>
           </a:ln>
           <a:effectLst/>
@@ -5207,7 +5641,7 @@
             <a:r>
               <a:rPr sz="1400" b="1">
                 <a:solidFill>
-                  <a:srgbClr val="1F2D33"/>
+                  <a:srgbClr val="0F1B14"/>
                 </a:solidFill>
                 <a:latin typeface="Segoe UI"/>
               </a:rPr>
@@ -5218,7 +5652,7 @@
       </p:sp>
       <p:sp>
         <p:nvSpPr>
-          <p:cNvPr id="5" name="Down Arrow 4"/>
+          <p:cNvPr id="7" name="Down Arrow 6"/>
           <p:cNvSpPr/>
           <p:nvPr/>
         </p:nvSpPr>
@@ -5231,7 +5665,7 @@
             <a:avLst/>
           </a:prstGeom>
           <a:solidFill>
-            <a:srgbClr val="90A4AE"/>
+            <a:srgbClr val="D6DDC9"/>
           </a:solidFill>
           <a:ln>
             <a:noFill/>
@@ -5262,7 +5696,7 @@
       </p:sp>
       <p:sp>
         <p:nvSpPr>
-          <p:cNvPr id="6" name="Rounded Rectangle 5"/>
+          <p:cNvPr id="8" name="Rounded Rectangle 7"/>
           <p:cNvSpPr/>
           <p:nvPr/>
         </p:nvSpPr>
@@ -5306,7 +5740,7 @@
             <a:r>
               <a:rPr sz="1500" b="1">
                 <a:solidFill>
-                  <a:srgbClr val="BF360C"/>
+                  <a:srgbClr val="92400E"/>
                 </a:solidFill>
                 <a:latin typeface="Segoe UI"/>
               </a:rPr>
@@ -5317,7 +5751,7 @@
       </p:sp>
       <p:sp>
         <p:nvSpPr>
-          <p:cNvPr id="7" name="Down Arrow 6"/>
+          <p:cNvPr id="9" name="Down Arrow 8"/>
           <p:cNvSpPr/>
           <p:nvPr/>
         </p:nvSpPr>
@@ -5330,7 +5764,7 @@
             <a:avLst/>
           </a:prstGeom>
           <a:solidFill>
-            <a:srgbClr val="90A4AE"/>
+            <a:srgbClr val="D6DDC9"/>
           </a:solidFill>
           <a:ln>
             <a:noFill/>
@@ -5361,7 +5795,7 @@
       </p:sp>
       <p:sp>
         <p:nvSpPr>
-          <p:cNvPr id="8" name="Rounded Rectangle 7"/>
+          <p:cNvPr id="10" name="Rounded Rectangle 9"/>
           <p:cNvSpPr/>
           <p:nvPr/>
         </p:nvSpPr>
@@ -5405,7 +5839,7 @@
             <a:r>
               <a:rPr sz="1400" b="1">
                 <a:solidFill>
-                  <a:srgbClr val="4A148C"/>
+                  <a:srgbClr val="4C1D95"/>
                 </a:solidFill>
                 <a:latin typeface="Segoe UI"/>
               </a:rPr>
@@ -5416,7 +5850,7 @@
       </p:sp>
       <p:sp>
         <p:nvSpPr>
-          <p:cNvPr id="9" name="Rounded Rectangle 8"/>
+          <p:cNvPr id="11" name="Rounded Rectangle 10"/>
           <p:cNvSpPr/>
           <p:nvPr/>
         </p:nvSpPr>
@@ -5460,7 +5894,7 @@
             <a:r>
               <a:rPr sz="1400" b="1">
                 <a:solidFill>
-                  <a:srgbClr val="4A148C"/>
+                  <a:srgbClr val="4C1D95"/>
                 </a:solidFill>
                 <a:latin typeface="Segoe UI"/>
               </a:rPr>
@@ -5471,7 +5905,7 @@
       </p:sp>
       <p:sp>
         <p:nvSpPr>
-          <p:cNvPr id="10" name="Down Arrow 9"/>
+          <p:cNvPr id="12" name="Down Arrow 11"/>
           <p:cNvSpPr/>
           <p:nvPr/>
         </p:nvSpPr>
@@ -5484,7 +5918,7 @@
             <a:avLst/>
           </a:prstGeom>
           <a:solidFill>
-            <a:srgbClr val="90A4AE"/>
+            <a:srgbClr val="D6DDC9"/>
           </a:solidFill>
           <a:ln>
             <a:noFill/>
@@ -5515,7 +5949,7 @@
       </p:sp>
       <p:sp>
         <p:nvSpPr>
-          <p:cNvPr id="11" name="Rounded Rectangle 10"/>
+          <p:cNvPr id="13" name="Rounded Rectangle 12"/>
           <p:cNvSpPr/>
           <p:nvPr/>
         </p:nvSpPr>
@@ -5528,7 +5962,7 @@
             <a:avLst/>
           </a:prstGeom>
           <a:solidFill>
-            <a:srgbClr val="E8F5E9"/>
+            <a:srgbClr val="EAF6DB"/>
           </a:solidFill>
           <a:ln w="31750">
             <a:solidFill>
@@ -5559,7 +5993,7 @@
             <a:r>
               <a:rPr sz="1500" b="1">
                 <a:solidFill>
-                  <a:srgbClr val="1B5E20"/>
+                  <a:srgbClr val="0C3B1F"/>
                 </a:solidFill>
                 <a:latin typeface="Segoe UI"/>
               </a:rPr>
@@ -5570,7 +6004,7 @@
       </p:sp>
       <p:sp>
         <p:nvSpPr>
-          <p:cNvPr id="12" name="Rounded Rectangle 11"/>
+          <p:cNvPr id="14" name="Rounded Rectangle 13"/>
           <p:cNvSpPr/>
           <p:nvPr/>
         </p:nvSpPr>
@@ -5583,7 +6017,7 @@
             <a:avLst/>
           </a:prstGeom>
           <a:solidFill>
-            <a:srgbClr val="E8F5E9"/>
+            <a:srgbClr val="EAF6DB"/>
           </a:solidFill>
           <a:ln w="31750">
             <a:solidFill>
@@ -5614,7 +6048,7 @@
             <a:r>
               <a:rPr sz="1500" b="1">
                 <a:solidFill>
-                  <a:srgbClr val="1B5E20"/>
+                  <a:srgbClr val="0C3B1F"/>
                 </a:solidFill>
                 <a:latin typeface="Segoe UI"/>
               </a:rPr>
@@ -5625,7 +6059,7 @@
       </p:sp>
       <p:sp>
         <p:nvSpPr>
-          <p:cNvPr id="13" name="Rounded Rectangle 12"/>
+          <p:cNvPr id="15" name="Rounded Rectangle 14"/>
           <p:cNvSpPr/>
           <p:nvPr/>
         </p:nvSpPr>
@@ -5638,7 +6072,7 @@
             <a:avLst/>
           </a:prstGeom>
           <a:solidFill>
-            <a:srgbClr val="E8F5E9"/>
+            <a:srgbClr val="EAF6DB"/>
           </a:solidFill>
           <a:ln w="31750">
             <a:solidFill>
@@ -5669,7 +6103,7 @@
             <a:r>
               <a:rPr sz="1500" b="1">
                 <a:solidFill>
-                  <a:srgbClr val="1B5E20"/>
+                  <a:srgbClr val="0C3B1F"/>
                 </a:solidFill>
                 <a:latin typeface="Segoe UI"/>
               </a:rPr>
@@ -5680,7 +6114,7 @@
       </p:sp>
       <p:sp>
         <p:nvSpPr>
-          <p:cNvPr id="14" name="Rounded Rectangle 13"/>
+          <p:cNvPr id="16" name="Rounded Rectangle 15"/>
           <p:cNvSpPr/>
           <p:nvPr/>
         </p:nvSpPr>
@@ -5693,7 +6127,7 @@
             <a:avLst/>
           </a:prstGeom>
           <a:solidFill>
-            <a:srgbClr val="E8F5E9"/>
+            <a:srgbClr val="EAF6DB"/>
           </a:solidFill>
           <a:ln w="31750">
             <a:solidFill>
@@ -5724,7 +6158,7 @@
             <a:r>
               <a:rPr sz="1500" b="1">
                 <a:solidFill>
-                  <a:srgbClr val="1B5E20"/>
+                  <a:srgbClr val="0C3B1F"/>
                 </a:solidFill>
                 <a:latin typeface="Segoe UI"/>
               </a:rPr>
@@ -5735,7 +6169,7 @@
       </p:sp>
       <p:sp>
         <p:nvSpPr>
-          <p:cNvPr id="15" name="Down Arrow 14"/>
+          <p:cNvPr id="17" name="Down Arrow 16"/>
           <p:cNvSpPr/>
           <p:nvPr/>
         </p:nvSpPr>
@@ -5748,7 +6182,7 @@
             <a:avLst/>
           </a:prstGeom>
           <a:solidFill>
-            <a:srgbClr val="90A4AE"/>
+            <a:srgbClr val="D6DDC9"/>
           </a:solidFill>
           <a:ln>
             <a:noFill/>
@@ -5779,7 +6213,7 @@
       </p:sp>
       <p:sp>
         <p:nvSpPr>
-          <p:cNvPr id="16" name="Rounded Rectangle 15"/>
+          <p:cNvPr id="18" name="Rounded Rectangle 17"/>
           <p:cNvSpPr/>
           <p:nvPr/>
         </p:nvSpPr>
@@ -5823,7 +6257,7 @@
             <a:r>
               <a:rPr sz="1400" b="1">
                 <a:solidFill>
-                  <a:srgbClr val="1F2D33"/>
+                  <a:srgbClr val="0F1B14"/>
                 </a:solidFill>
                 <a:latin typeface="Segoe UI"/>
               </a:rPr>
@@ -5834,7 +6268,7 @@
       </p:sp>
       <p:sp>
         <p:nvSpPr>
-          <p:cNvPr id="17" name="Rounded Rectangle 16"/>
+          <p:cNvPr id="19" name="Rounded Rectangle 18"/>
           <p:cNvSpPr/>
           <p:nvPr/>
         </p:nvSpPr>
@@ -5878,7 +6312,7 @@
             <a:r>
               <a:rPr sz="1400" b="1">
                 <a:solidFill>
-                  <a:srgbClr val="1F2D33"/>
+                  <a:srgbClr val="0F1B14"/>
                 </a:solidFill>
                 <a:latin typeface="Segoe UI"/>
               </a:rPr>
@@ -5889,7 +6323,7 @@
       </p:sp>
       <p:sp>
         <p:nvSpPr>
-          <p:cNvPr id="18" name="Rounded Rectangle 17"/>
+          <p:cNvPr id="20" name="Rounded Rectangle 19"/>
           <p:cNvSpPr/>
           <p:nvPr/>
         </p:nvSpPr>
@@ -5933,7 +6367,7 @@
             <a:r>
               <a:rPr sz="1400" b="1">
                 <a:solidFill>
-                  <a:srgbClr val="1F2D33"/>
+                  <a:srgbClr val="0F1B14"/>
                 </a:solidFill>
                 <a:latin typeface="Segoe UI"/>
               </a:rPr>
@@ -5944,7 +6378,7 @@
       </p:sp>
       <p:sp>
         <p:nvSpPr>
-          <p:cNvPr id="19" name="Rounded Rectangle 18"/>
+          <p:cNvPr id="21" name="Rounded Rectangle 20"/>
           <p:cNvSpPr/>
           <p:nvPr/>
         </p:nvSpPr>
@@ -5988,7 +6422,7 @@
             <a:r>
               <a:rPr sz="1400" b="1">
                 <a:solidFill>
-                  <a:srgbClr val="1F2D33"/>
+                  <a:srgbClr val="0F1B14"/>
                 </a:solidFill>
                 <a:latin typeface="Segoe UI"/>
               </a:rPr>
@@ -5999,7 +6433,7 @@
       </p:sp>
       <p:sp>
         <p:nvSpPr>
-          <p:cNvPr id="20" name="Down Arrow 19"/>
+          <p:cNvPr id="22" name="Down Arrow 21"/>
           <p:cNvSpPr/>
           <p:nvPr/>
         </p:nvSpPr>
@@ -6012,7 +6446,7 @@
             <a:avLst/>
           </a:prstGeom>
           <a:solidFill>
-            <a:srgbClr val="90A4AE"/>
+            <a:srgbClr val="D6DDC9"/>
           </a:solidFill>
           <a:ln>
             <a:noFill/>
@@ -6043,7 +6477,7 @@
       </p:sp>
       <p:sp>
         <p:nvSpPr>
-          <p:cNvPr id="21" name="Rounded Rectangle 20"/>
+          <p:cNvPr id="23" name="Rounded Rectangle 22"/>
           <p:cNvSpPr/>
           <p:nvPr/>
         </p:nvSpPr>
@@ -6098,7 +6532,7 @@
       </p:sp>
       <p:sp>
         <p:nvSpPr>
-          <p:cNvPr id="22" name="Rounded Rectangle 21"/>
+          <p:cNvPr id="24" name="Rounded Rectangle 23"/>
           <p:cNvSpPr/>
           <p:nvPr/>
         </p:nvSpPr>
@@ -6111,12 +6545,10 @@
             <a:avLst/>
           </a:prstGeom>
           <a:solidFill>
-            <a:srgbClr val="E8F5E9"/>
+            <a:srgbClr val="0C3B1F"/>
           </a:solidFill>
           <a:ln>
-            <a:solidFill>
-              <a:srgbClr val="E8F5E9"/>
-            </a:solidFill>
+            <a:noFill/>
           </a:ln>
           <a:effectLst/>
         </p:spPr>
@@ -6135,19 +6567,63 @@
           </a:fontRef>
         </p:style>
         <p:txBody>
-          <a:bodyPr rtlCol="0" anchor="ctr" wrap="square" lIns="228600" rIns="228600"/>
+          <a:bodyPr rtlCol="0" anchor="ctr" wrap="square" lIns="292608" rIns="228600"/>
           <a:lstStyle/>
           <a:p>
             <a:pPr algn="ctr"/>
             <a:r>
               <a:rPr sz="1800" b="0">
                 <a:solidFill>
-                  <a:srgbClr val="1B5E20"/>
+                  <a:srgbClr val="F2FFE0"/>
                 </a:solidFill>
                 <a:latin typeface="Segoe UI"/>
               </a:rPr>
               <a:t>A única porta de entrada é o gateway; cada serviço só escreve no seu banco.</a:t>
             </a:r>
+          </a:p>
+        </p:txBody>
+      </p:sp>
+      <p:sp>
+        <p:nvSpPr>
+          <p:cNvPr id="25" name="Rectangle 24"/>
+          <p:cNvSpPr/>
+          <p:nvPr/>
+        </p:nvSpPr>
+        <p:spPr>
+          <a:xfrm>
+            <a:off x="685800" y="5669280"/>
+            <a:ext cx="100584" cy="868680"/>
+          </a:xfrm>
+          <a:prstGeom prst="rect">
+            <a:avLst/>
+          </a:prstGeom>
+          <a:solidFill>
+            <a:srgbClr val="A3E635"/>
+          </a:solidFill>
+          <a:ln>
+            <a:noFill/>
+          </a:ln>
+          <a:effectLst/>
+        </p:spPr>
+        <p:style>
+          <a:lnRef idx="1">
+            <a:schemeClr val="accent1"/>
+          </a:lnRef>
+          <a:fillRef idx="3">
+            <a:schemeClr val="accent1"/>
+          </a:fillRef>
+          <a:effectRef idx="2">
+            <a:schemeClr val="accent1"/>
+          </a:effectRef>
+          <a:fontRef idx="minor">
+            <a:schemeClr val="lt1"/>
+          </a:fontRef>
+        </p:style>
+        <p:txBody>
+          <a:bodyPr rtlCol="0" anchor="ctr"/>
+          <a:lstStyle/>
+          <a:p>
+            <a:pPr algn="ctr"/>
           </a:p>
         </p:txBody>
       </p:sp>
@@ -6165,7 +6641,7 @@
     <p:bg>
       <p:bgPr>
         <a:solidFill>
-          <a:srgbClr val="FBFBF6"/>
+          <a:srgbClr val="F7F9F0"/>
         </a:solidFill>
         <a:effectLst/>
       </p:bgPr>
@@ -6179,14 +6655,58 @@
       <p:grpSpPr/>
       <p:sp>
         <p:nvSpPr>
-          <p:cNvPr id="2" name="TextBox 1"/>
+          <p:cNvPr id="2" name="Rectangle 1"/>
+          <p:cNvSpPr/>
+          <p:nvPr/>
+        </p:nvSpPr>
+        <p:spPr>
+          <a:xfrm>
+            <a:off x="0" y="0"/>
+            <a:ext cx="12191695" cy="73152"/>
+          </a:xfrm>
+          <a:prstGeom prst="rect">
+            <a:avLst/>
+          </a:prstGeom>
+          <a:solidFill>
+            <a:srgbClr val="1E6B33"/>
+          </a:solidFill>
+          <a:ln>
+            <a:noFill/>
+          </a:ln>
+          <a:effectLst/>
+        </p:spPr>
+        <p:style>
+          <a:lnRef idx="1">
+            <a:schemeClr val="accent1"/>
+          </a:lnRef>
+          <a:fillRef idx="3">
+            <a:schemeClr val="accent1"/>
+          </a:fillRef>
+          <a:effectRef idx="2">
+            <a:schemeClr val="accent1"/>
+          </a:effectRef>
+          <a:fontRef idx="minor">
+            <a:schemeClr val="lt1"/>
+          </a:fontRef>
+        </p:style>
+        <p:txBody>
+          <a:bodyPr rtlCol="0" anchor="ctr"/>
+          <a:lstStyle/>
+          <a:p>
+            <a:pPr algn="ctr"/>
+          </a:p>
+        </p:txBody>
+      </p:sp>
+      <p:sp>
+        <p:nvSpPr>
+          <p:cNvPr id="3" name="TextBox 2"/>
           <p:cNvSpPr txBox="1"/>
           <p:nvPr/>
         </p:nvSpPr>
         <p:spPr>
           <a:xfrm>
-            <a:off x="685800" y="411480"/>
-            <a:ext cx="10881360" cy="914400"/>
+            <a:off x="685800" y="384048"/>
+            <a:ext cx="10881360" cy="822960"/>
           </a:xfrm>
           <a:prstGeom prst="rect">
             <a:avLst/>
@@ -6201,11 +6721,11 @@
           <a:p>
             <a:pPr algn="l"/>
             <a:r>
-              <a:rPr sz="3600" b="1">
-                <a:solidFill>
-                  <a:srgbClr val="1B5E20"/>
-                </a:solidFill>
-                <a:latin typeface="Segoe UI"/>
+              <a:rPr sz="3800" b="1">
+                <a:solidFill>
+                  <a:srgbClr val="0C3B1F"/>
+                </a:solidFill>
+                <a:latin typeface="Bahnschrift"/>
               </a:rPr>
               <a:t>Quatro serviços e por que esse corte</a:t>
             </a:r>
@@ -6214,13 +6734,57 @@
       </p:sp>
       <p:sp>
         <p:nvSpPr>
-          <p:cNvPr id="3" name="TextBox 2"/>
+          <p:cNvPr id="4" name="Rounded Rectangle 3"/>
+          <p:cNvSpPr/>
+          <p:nvPr/>
+        </p:nvSpPr>
+        <p:spPr>
+          <a:xfrm>
+            <a:off x="713232" y="1152144"/>
+            <a:ext cx="960120" cy="68580"/>
+          </a:xfrm>
+          <a:prstGeom prst="roundRect">
+            <a:avLst/>
+          </a:prstGeom>
+          <a:solidFill>
+            <a:srgbClr val="A3E635"/>
+          </a:solidFill>
+          <a:ln>
+            <a:noFill/>
+          </a:ln>
+          <a:effectLst/>
+        </p:spPr>
+        <p:style>
+          <a:lnRef idx="1">
+            <a:schemeClr val="accent1"/>
+          </a:lnRef>
+          <a:fillRef idx="3">
+            <a:schemeClr val="accent1"/>
+          </a:fillRef>
+          <a:effectRef idx="2">
+            <a:schemeClr val="accent1"/>
+          </a:effectRef>
+          <a:fontRef idx="minor">
+            <a:schemeClr val="lt1"/>
+          </a:fontRef>
+        </p:style>
+        <p:txBody>
+          <a:bodyPr rtlCol="0" anchor="ctr"/>
+          <a:lstStyle/>
+          <a:p>
+            <a:pPr algn="ctr"/>
+          </a:p>
+        </p:txBody>
+      </p:sp>
+      <p:sp>
+        <p:nvSpPr>
+          <p:cNvPr id="5" name="TextBox 4"/>
           <p:cNvSpPr txBox="1"/>
           <p:nvPr/>
         </p:nvSpPr>
         <p:spPr>
           <a:xfrm>
-            <a:off x="685800" y="1463040"/>
+            <a:off x="685800" y="1481328"/>
             <a:ext cx="10881360" cy="3977639"/>
           </a:xfrm>
           <a:prstGeom prst="rect">
@@ -6245,7 +6809,7 @@
             <a:r>
               <a:rPr sz="2600" b="1">
                 <a:solidFill>
-                  <a:srgbClr val="1B5E20"/>
+                  <a:srgbClr val="0C3B1F"/>
                 </a:solidFill>
                 <a:latin typeface="Segoe UI"/>
               </a:rPr>
@@ -6254,7 +6818,7 @@
             <a:r>
               <a:rPr sz="2600" b="1">
                 <a:solidFill>
-                  <a:srgbClr val="1B5E20"/>
+                  <a:srgbClr val="0C3B1F"/>
                 </a:solidFill>
                 <a:latin typeface="Segoe UI"/>
               </a:rPr>
@@ -6263,7 +6827,7 @@
             <a:r>
               <a:rPr sz="2600" b="0">
                 <a:solidFill>
-                  <a:srgbClr val="1F2D33"/>
+                  <a:srgbClr val="0F1B14"/>
                 </a:solidFill>
                 <a:latin typeface="Segoe UI"/>
               </a:rPr>
@@ -6282,7 +6846,7 @@
             <a:r>
               <a:rPr sz="2600" b="1">
                 <a:solidFill>
-                  <a:srgbClr val="1B5E20"/>
+                  <a:srgbClr val="0C3B1F"/>
                 </a:solidFill>
                 <a:latin typeface="Segoe UI"/>
               </a:rPr>
@@ -6291,7 +6855,7 @@
             <a:r>
               <a:rPr sz="2600" b="1">
                 <a:solidFill>
-                  <a:srgbClr val="1B5E20"/>
+                  <a:srgbClr val="0C3B1F"/>
                 </a:solidFill>
                 <a:latin typeface="Segoe UI"/>
               </a:rPr>
@@ -6300,7 +6864,7 @@
             <a:r>
               <a:rPr sz="2600" b="0">
                 <a:solidFill>
-                  <a:srgbClr val="1F2D33"/>
+                  <a:srgbClr val="0F1B14"/>
                 </a:solidFill>
                 <a:latin typeface="Segoe UI"/>
               </a:rPr>
@@ -6319,7 +6883,7 @@
             <a:r>
               <a:rPr sz="2600" b="1">
                 <a:solidFill>
-                  <a:srgbClr val="1B5E20"/>
+                  <a:srgbClr val="0C3B1F"/>
                 </a:solidFill>
                 <a:latin typeface="Segoe UI"/>
               </a:rPr>
@@ -6328,7 +6892,7 @@
             <a:r>
               <a:rPr sz="2600" b="1">
                 <a:solidFill>
-                  <a:srgbClr val="1B5E20"/>
+                  <a:srgbClr val="0C3B1F"/>
                 </a:solidFill>
                 <a:latin typeface="Segoe UI"/>
               </a:rPr>
@@ -6337,7 +6901,7 @@
             <a:r>
               <a:rPr sz="2600" b="0">
                 <a:solidFill>
-                  <a:srgbClr val="1F2D33"/>
+                  <a:srgbClr val="0F1B14"/>
                 </a:solidFill>
                 <a:latin typeface="Segoe UI"/>
               </a:rPr>
@@ -6356,7 +6920,7 @@
             <a:r>
               <a:rPr sz="2600" b="1">
                 <a:solidFill>
-                  <a:srgbClr val="1B5E20"/>
+                  <a:srgbClr val="0C3B1F"/>
                 </a:solidFill>
                 <a:latin typeface="Segoe UI"/>
               </a:rPr>
@@ -6365,7 +6929,7 @@
             <a:r>
               <a:rPr sz="2600" b="1">
                 <a:solidFill>
-                  <a:srgbClr val="1B5E20"/>
+                  <a:srgbClr val="0C3B1F"/>
                 </a:solidFill>
                 <a:latin typeface="Segoe UI"/>
               </a:rPr>
@@ -6374,7 +6938,7 @@
             <a:r>
               <a:rPr sz="2600" b="0">
                 <a:solidFill>
-                  <a:srgbClr val="1F2D33"/>
+                  <a:srgbClr val="0F1B14"/>
                 </a:solidFill>
                 <a:latin typeface="Segoe UI"/>
               </a:rPr>
@@ -6385,7 +6949,7 @@
       </p:sp>
       <p:sp>
         <p:nvSpPr>
-          <p:cNvPr id="4" name="Rounded Rectangle 3"/>
+          <p:cNvPr id="6" name="Rounded Rectangle 5"/>
           <p:cNvSpPr/>
           <p:nvPr/>
         </p:nvSpPr>
@@ -6398,12 +6962,10 @@
             <a:avLst/>
           </a:prstGeom>
           <a:solidFill>
-            <a:srgbClr val="E8F5E9"/>
+            <a:srgbClr val="0C3B1F"/>
           </a:solidFill>
           <a:ln>
-            <a:solidFill>
-              <a:srgbClr val="E8F5E9"/>
-            </a:solidFill>
+            <a:noFill/>
           </a:ln>
           <a:effectLst/>
         </p:spPr>
@@ -6422,19 +6984,63 @@
           </a:fontRef>
         </p:style>
         <p:txBody>
-          <a:bodyPr rtlCol="0" anchor="ctr" wrap="square" lIns="228600" rIns="228600"/>
+          <a:bodyPr rtlCol="0" anchor="ctr" wrap="square" lIns="292608" rIns="228600"/>
           <a:lstStyle/>
           <a:p>
             <a:pPr algn="ctr"/>
             <a:r>
               <a:rPr sz="1800" b="0">
                 <a:solidFill>
-                  <a:srgbClr val="1B5E20"/>
+                  <a:srgbClr val="F2FFE0"/>
                 </a:solidFill>
                 <a:latin typeface="Segoe UI"/>
               </a:rPr>
               <a:t>Cortamos por ciclo de vida e regra própria, não por tabela — por isso não existe um "serviço de cadastros".</a:t>
             </a:r>
+          </a:p>
+        </p:txBody>
+      </p:sp>
+      <p:sp>
+        <p:nvSpPr>
+          <p:cNvPr id="7" name="Rectangle 6"/>
+          <p:cNvSpPr/>
+          <p:nvPr/>
+        </p:nvSpPr>
+        <p:spPr>
+          <a:xfrm>
+            <a:off x="685800" y="5532120"/>
+            <a:ext cx="100584" cy="868680"/>
+          </a:xfrm>
+          <a:prstGeom prst="rect">
+            <a:avLst/>
+          </a:prstGeom>
+          <a:solidFill>
+            <a:srgbClr val="A3E635"/>
+          </a:solidFill>
+          <a:ln>
+            <a:noFill/>
+          </a:ln>
+          <a:effectLst/>
+        </p:spPr>
+        <p:style>
+          <a:lnRef idx="1">
+            <a:schemeClr val="accent1"/>
+          </a:lnRef>
+          <a:fillRef idx="3">
+            <a:schemeClr val="accent1"/>
+          </a:fillRef>
+          <a:effectRef idx="2">
+            <a:schemeClr val="accent1"/>
+          </a:effectRef>
+          <a:fontRef idx="minor">
+            <a:schemeClr val="lt1"/>
+          </a:fontRef>
+        </p:style>
+        <p:txBody>
+          <a:bodyPr rtlCol="0" anchor="ctr"/>
+          <a:lstStyle/>
+          <a:p>
+            <a:pPr algn="ctr"/>
           </a:p>
         </p:txBody>
       </p:sp>
@@ -6452,7 +7058,7 @@
     <p:bg>
       <p:bgPr>
         <a:solidFill>
-          <a:srgbClr val="FBFBF6"/>
+          <a:srgbClr val="F7F9F0"/>
         </a:solidFill>
         <a:effectLst/>
       </p:bgPr>
@@ -6466,14 +7072,58 @@
       <p:grpSpPr/>
       <p:sp>
         <p:nvSpPr>
-          <p:cNvPr id="2" name="TextBox 1"/>
+          <p:cNvPr id="2" name="Rectangle 1"/>
+          <p:cNvSpPr/>
+          <p:nvPr/>
+        </p:nvSpPr>
+        <p:spPr>
+          <a:xfrm>
+            <a:off x="0" y="0"/>
+            <a:ext cx="12191695" cy="73152"/>
+          </a:xfrm>
+          <a:prstGeom prst="rect">
+            <a:avLst/>
+          </a:prstGeom>
+          <a:solidFill>
+            <a:srgbClr val="1E6B33"/>
+          </a:solidFill>
+          <a:ln>
+            <a:noFill/>
+          </a:ln>
+          <a:effectLst/>
+        </p:spPr>
+        <p:style>
+          <a:lnRef idx="1">
+            <a:schemeClr val="accent1"/>
+          </a:lnRef>
+          <a:fillRef idx="3">
+            <a:schemeClr val="accent1"/>
+          </a:fillRef>
+          <a:effectRef idx="2">
+            <a:schemeClr val="accent1"/>
+          </a:effectRef>
+          <a:fontRef idx="minor">
+            <a:schemeClr val="lt1"/>
+          </a:fontRef>
+        </p:style>
+        <p:txBody>
+          <a:bodyPr rtlCol="0" anchor="ctr"/>
+          <a:lstStyle/>
+          <a:p>
+            <a:pPr algn="ctr"/>
+          </a:p>
+        </p:txBody>
+      </p:sp>
+      <p:sp>
+        <p:nvSpPr>
+          <p:cNvPr id="3" name="TextBox 2"/>
           <p:cNvSpPr txBox="1"/>
           <p:nvPr/>
         </p:nvSpPr>
         <p:spPr>
           <a:xfrm>
-            <a:off x="685800" y="411480"/>
-            <a:ext cx="10881360" cy="914400"/>
+            <a:off x="685800" y="384048"/>
+            <a:ext cx="10881360" cy="822960"/>
           </a:xfrm>
           <a:prstGeom prst="rect">
             <a:avLst/>
@@ -6488,11 +7138,11 @@
           <a:p>
             <a:pPr algn="l"/>
             <a:r>
-              <a:rPr sz="3600" b="1">
-                <a:solidFill>
-                  <a:srgbClr val="1B5E20"/>
-                </a:solidFill>
-                <a:latin typeface="Segoe UI"/>
+              <a:rPr sz="3800" b="1">
+                <a:solidFill>
+                  <a:srgbClr val="0C3B1F"/>
+                </a:solidFill>
+                <a:latin typeface="Bahnschrift"/>
               </a:rPr>
               <a:t>Contratos REST</a:t>
             </a:r>
@@ -6501,13 +7151,57 @@
       </p:sp>
       <p:sp>
         <p:nvSpPr>
-          <p:cNvPr id="3" name="TextBox 2"/>
+          <p:cNvPr id="4" name="Rounded Rectangle 3"/>
+          <p:cNvSpPr/>
+          <p:nvPr/>
+        </p:nvSpPr>
+        <p:spPr>
+          <a:xfrm>
+            <a:off x="713232" y="1152144"/>
+            <a:ext cx="960120" cy="68580"/>
+          </a:xfrm>
+          <a:prstGeom prst="roundRect">
+            <a:avLst/>
+          </a:prstGeom>
+          <a:solidFill>
+            <a:srgbClr val="A3E635"/>
+          </a:solidFill>
+          <a:ln>
+            <a:noFill/>
+          </a:ln>
+          <a:effectLst/>
+        </p:spPr>
+        <p:style>
+          <a:lnRef idx="1">
+            <a:schemeClr val="accent1"/>
+          </a:lnRef>
+          <a:fillRef idx="3">
+            <a:schemeClr val="accent1"/>
+          </a:fillRef>
+          <a:effectRef idx="2">
+            <a:schemeClr val="accent1"/>
+          </a:effectRef>
+          <a:fontRef idx="minor">
+            <a:schemeClr val="lt1"/>
+          </a:fontRef>
+        </p:style>
+        <p:txBody>
+          <a:bodyPr rtlCol="0" anchor="ctr"/>
+          <a:lstStyle/>
+          <a:p>
+            <a:pPr algn="ctr"/>
+          </a:p>
+        </p:txBody>
+      </p:sp>
+      <p:sp>
+        <p:nvSpPr>
+          <p:cNvPr id="5" name="TextBox 4"/>
           <p:cNvSpPr txBox="1"/>
           <p:nvPr/>
         </p:nvSpPr>
         <p:spPr>
           <a:xfrm>
-            <a:off x="685800" y="1463040"/>
+            <a:off x="685800" y="1481328"/>
             <a:ext cx="10881360" cy="3977639"/>
           </a:xfrm>
           <a:prstGeom prst="rect">
@@ -6532,7 +7226,7 @@
             <a:r>
               <a:rPr sz="2400" b="1">
                 <a:solidFill>
-                  <a:srgbClr val="1B5E20"/>
+                  <a:srgbClr val="0C3B1F"/>
                 </a:solidFill>
                 <a:latin typeface="Segoe UI"/>
               </a:rPr>
@@ -6541,7 +7235,7 @@
             <a:r>
               <a:rPr sz="2400" b="0">
                 <a:solidFill>
-                  <a:srgbClr val="1F2D33"/>
+                  <a:srgbClr val="0F1B14"/>
                 </a:solidFill>
                 <a:latin typeface="Segoe UI"/>
               </a:rPr>
@@ -6550,7 +7244,7 @@
             <a:r>
               <a:rPr sz="2400" b="1">
                 <a:solidFill>
-                  <a:srgbClr val="1B5E20"/>
+                  <a:srgbClr val="0C3B1F"/>
                 </a:solidFill>
                 <a:latin typeface="Segoe UI"/>
               </a:rPr>
@@ -6559,7 +7253,7 @@
             <a:r>
               <a:rPr sz="2400" b="0">
                 <a:solidFill>
-                  <a:srgbClr val="1F2D33"/>
+                  <a:srgbClr val="0F1B14"/>
                 </a:solidFill>
                 <a:latin typeface="Segoe UI"/>
               </a:rPr>
@@ -6578,7 +7272,7 @@
             <a:r>
               <a:rPr sz="2400" b="1">
                 <a:solidFill>
-                  <a:srgbClr val="1B5E20"/>
+                  <a:srgbClr val="0C3B1F"/>
                 </a:solidFill>
                 <a:latin typeface="Segoe UI"/>
               </a:rPr>
@@ -6587,7 +7281,7 @@
             <a:r>
               <a:rPr sz="2400" b="0">
                 <a:solidFill>
-                  <a:srgbClr val="1F2D33"/>
+                  <a:srgbClr val="0F1B14"/>
                 </a:solidFill>
                 <a:latin typeface="Segoe UI"/>
               </a:rPr>
@@ -6596,7 +7290,7 @@
             <a:r>
               <a:rPr sz="2400" b="1">
                 <a:solidFill>
-                  <a:srgbClr val="1B5E20"/>
+                  <a:srgbClr val="0C3B1F"/>
                 </a:solidFill>
                 <a:latin typeface="Segoe UI"/>
               </a:rPr>
@@ -6605,7 +7299,7 @@
             <a:r>
               <a:rPr sz="2400" b="0">
                 <a:solidFill>
-                  <a:srgbClr val="1F2D33"/>
+                  <a:srgbClr val="0F1B14"/>
                 </a:solidFill>
                 <a:latin typeface="Segoe UI"/>
               </a:rPr>
@@ -6614,7 +7308,7 @@
             <a:r>
               <a:rPr sz="2400" b="1">
                 <a:solidFill>
-                  <a:srgbClr val="1B5E20"/>
+                  <a:srgbClr val="0C3B1F"/>
                 </a:solidFill>
                 <a:latin typeface="Segoe UI"/>
               </a:rPr>
@@ -6623,7 +7317,7 @@
             <a:r>
               <a:rPr sz="2400" b="0">
                 <a:solidFill>
-                  <a:srgbClr val="1F2D33"/>
+                  <a:srgbClr val="0F1B14"/>
                 </a:solidFill>
                 <a:latin typeface="Segoe UI"/>
               </a:rPr>
@@ -6632,7 +7326,7 @@
             <a:r>
               <a:rPr sz="2400" b="1">
                 <a:solidFill>
-                  <a:srgbClr val="1B5E20"/>
+                  <a:srgbClr val="0C3B1F"/>
                 </a:solidFill>
                 <a:latin typeface="Segoe UI"/>
               </a:rPr>
@@ -6641,7 +7335,7 @@
             <a:r>
               <a:rPr sz="2400" b="0">
                 <a:solidFill>
-                  <a:srgbClr val="1F2D33"/>
+                  <a:srgbClr val="0F1B14"/>
                 </a:solidFill>
                 <a:latin typeface="Segoe UI"/>
               </a:rPr>
@@ -6650,7 +7344,7 @@
             <a:r>
               <a:rPr sz="2400" b="1">
                 <a:solidFill>
-                  <a:srgbClr val="1B5E20"/>
+                  <a:srgbClr val="0C3B1F"/>
                 </a:solidFill>
                 <a:latin typeface="Segoe UI"/>
               </a:rPr>
@@ -6659,7 +7353,7 @@
             <a:r>
               <a:rPr sz="2400" b="0">
                 <a:solidFill>
-                  <a:srgbClr val="1F2D33"/>
+                  <a:srgbClr val="0F1B14"/>
                 </a:solidFill>
                 <a:latin typeface="Segoe UI"/>
               </a:rPr>
@@ -6678,7 +7372,7 @@
             <a:r>
               <a:rPr sz="2400" b="1">
                 <a:solidFill>
-                  <a:srgbClr val="1B5E20"/>
+                  <a:srgbClr val="0C3B1F"/>
                 </a:solidFill>
                 <a:latin typeface="Segoe UI"/>
               </a:rPr>
@@ -6687,7 +7381,7 @@
             <a:r>
               <a:rPr sz="2400" b="0">
                 <a:solidFill>
-                  <a:srgbClr val="1F2D33"/>
+                  <a:srgbClr val="0F1B14"/>
                 </a:solidFill>
                 <a:latin typeface="Segoe UI"/>
               </a:rPr>
@@ -6706,7 +7400,7 @@
             <a:r>
               <a:rPr sz="2400" b="1">
                 <a:solidFill>
-                  <a:srgbClr val="1B5E20"/>
+                  <a:srgbClr val="0C3B1F"/>
                 </a:solidFill>
                 <a:latin typeface="Segoe UI"/>
               </a:rPr>
@@ -6715,7 +7409,7 @@
             <a:r>
               <a:rPr sz="2400" b="1">
                 <a:solidFill>
-                  <a:srgbClr val="1B5E20"/>
+                  <a:srgbClr val="0C3B1F"/>
                 </a:solidFill>
                 <a:latin typeface="Segoe UI"/>
               </a:rPr>
@@ -6724,7 +7418,7 @@
             <a:r>
               <a:rPr sz="2400" b="0">
                 <a:solidFill>
-                  <a:srgbClr val="1F2D33"/>
+                  <a:srgbClr val="0F1B14"/>
                 </a:solidFill>
                 <a:latin typeface="Segoe UI"/>
               </a:rPr>
@@ -6735,7 +7429,7 @@
       </p:sp>
       <p:sp>
         <p:nvSpPr>
-          <p:cNvPr id="4" name="Rounded Rectangle 3"/>
+          <p:cNvPr id="6" name="Rounded Rectangle 5"/>
           <p:cNvSpPr/>
           <p:nvPr/>
         </p:nvSpPr>
@@ -6748,12 +7442,10 @@
             <a:avLst/>
           </a:prstGeom>
           <a:solidFill>
-            <a:srgbClr val="E8F5E9"/>
+            <a:srgbClr val="0C3B1F"/>
           </a:solidFill>
           <a:ln>
-            <a:solidFill>
-              <a:srgbClr val="E8F5E9"/>
-            </a:solidFill>
+            <a:noFill/>
           </a:ln>
           <a:effectLst/>
         </p:spPr>
@@ -6772,19 +7464,63 @@
           </a:fontRef>
         </p:style>
         <p:txBody>
-          <a:bodyPr rtlCol="0" anchor="ctr" wrap="square" lIns="228600" rIns="228600"/>
+          <a:bodyPr rtlCol="0" anchor="ctr" wrap="square" lIns="292608" rIns="228600"/>
           <a:lstStyle/>
           <a:p>
             <a:pPr algn="ctr"/>
             <a:r>
               <a:rPr sz="1800" b="0">
                 <a:solidFill>
-                  <a:srgbClr val="1B5E20"/>
+                  <a:srgbClr val="F2FFE0"/>
                 </a:solidFill>
                 <a:latin typeface="Segoe UI"/>
               </a:rPr>
               <a:t>O contrato é executável: validamos os seis arquivos com Redocly e um script de cobertura.</a:t>
             </a:r>
+          </a:p>
+        </p:txBody>
+      </p:sp>
+      <p:sp>
+        <p:nvSpPr>
+          <p:cNvPr id="7" name="Rectangle 6"/>
+          <p:cNvSpPr/>
+          <p:nvPr/>
+        </p:nvSpPr>
+        <p:spPr>
+          <a:xfrm>
+            <a:off x="685800" y="5532120"/>
+            <a:ext cx="100584" cy="868680"/>
+          </a:xfrm>
+          <a:prstGeom prst="rect">
+            <a:avLst/>
+          </a:prstGeom>
+          <a:solidFill>
+            <a:srgbClr val="A3E635"/>
+          </a:solidFill>
+          <a:ln>
+            <a:noFill/>
+          </a:ln>
+          <a:effectLst/>
+        </p:spPr>
+        <p:style>
+          <a:lnRef idx="1">
+            <a:schemeClr val="accent1"/>
+          </a:lnRef>
+          <a:fillRef idx="3">
+            <a:schemeClr val="accent1"/>
+          </a:fillRef>
+          <a:effectRef idx="2">
+            <a:schemeClr val="accent1"/>
+          </a:effectRef>
+          <a:fontRef idx="minor">
+            <a:schemeClr val="lt1"/>
+          </a:fontRef>
+        </p:style>
+        <p:txBody>
+          <a:bodyPr rtlCol="0" anchor="ctr"/>
+          <a:lstStyle/>
+          <a:p>
+            <a:pPr algn="ctr"/>
           </a:p>
         </p:txBody>
       </p:sp>
@@ -6802,7 +7538,7 @@
     <p:bg>
       <p:bgPr>
         <a:solidFill>
-          <a:srgbClr val="FBFBF6"/>
+          <a:srgbClr val="F7F9F0"/>
         </a:solidFill>
         <a:effectLst/>
       </p:bgPr>
@@ -6816,14 +7552,58 @@
       <p:grpSpPr/>
       <p:sp>
         <p:nvSpPr>
-          <p:cNvPr id="2" name="TextBox 1"/>
+          <p:cNvPr id="2" name="Rectangle 1"/>
+          <p:cNvSpPr/>
+          <p:nvPr/>
+        </p:nvSpPr>
+        <p:spPr>
+          <a:xfrm>
+            <a:off x="0" y="0"/>
+            <a:ext cx="12191695" cy="73152"/>
+          </a:xfrm>
+          <a:prstGeom prst="rect">
+            <a:avLst/>
+          </a:prstGeom>
+          <a:solidFill>
+            <a:srgbClr val="1E6B33"/>
+          </a:solidFill>
+          <a:ln>
+            <a:noFill/>
+          </a:ln>
+          <a:effectLst/>
+        </p:spPr>
+        <p:style>
+          <a:lnRef idx="1">
+            <a:schemeClr val="accent1"/>
+          </a:lnRef>
+          <a:fillRef idx="3">
+            <a:schemeClr val="accent1"/>
+          </a:fillRef>
+          <a:effectRef idx="2">
+            <a:schemeClr val="accent1"/>
+          </a:effectRef>
+          <a:fontRef idx="minor">
+            <a:schemeClr val="lt1"/>
+          </a:fontRef>
+        </p:style>
+        <p:txBody>
+          <a:bodyPr rtlCol="0" anchor="ctr"/>
+          <a:lstStyle/>
+          <a:p>
+            <a:pPr algn="ctr"/>
+          </a:p>
+        </p:txBody>
+      </p:sp>
+      <p:sp>
+        <p:nvSpPr>
+          <p:cNvPr id="3" name="TextBox 2"/>
           <p:cNvSpPr txBox="1"/>
           <p:nvPr/>
         </p:nvSpPr>
         <p:spPr>
           <a:xfrm>
-            <a:off x="685800" y="411480"/>
-            <a:ext cx="10881360" cy="914400"/>
+            <a:off x="685800" y="384048"/>
+            <a:ext cx="10881360" cy="822960"/>
           </a:xfrm>
           <a:prstGeom prst="rect">
             <a:avLst/>
@@ -6838,11 +7618,11 @@
           <a:p>
             <a:pPr algn="l"/>
             <a:r>
-              <a:rPr sz="3600" b="1">
-                <a:solidFill>
-                  <a:srgbClr val="1B5E20"/>
-                </a:solidFill>
-                <a:latin typeface="Segoe UI"/>
+              <a:rPr sz="3800" b="1">
+                <a:solidFill>
+                  <a:srgbClr val="0C3B1F"/>
+                </a:solidFill>
+                <a:latin typeface="Bahnschrift"/>
               </a:rPr>
               <a:t>Gateway e dois BFFs</a:t>
             </a:r>
@@ -6851,20 +7631,64 @@
       </p:sp>
       <p:sp>
         <p:nvSpPr>
-          <p:cNvPr id="3" name="Rounded Rectangle 2"/>
+          <p:cNvPr id="4" name="Rounded Rectangle 3"/>
           <p:cNvSpPr/>
           <p:nvPr/>
         </p:nvSpPr>
         <p:spPr>
           <a:xfrm>
-            <a:off x="685800" y="1371600"/>
-            <a:ext cx="5349240" cy="2194560"/>
+            <a:off x="713232" y="1152144"/>
+            <a:ext cx="960120" cy="68580"/>
           </a:xfrm>
           <a:prstGeom prst="roundRect">
             <a:avLst/>
           </a:prstGeom>
           <a:solidFill>
-            <a:srgbClr val="FFEBEE"/>
+            <a:srgbClr val="A3E635"/>
+          </a:solidFill>
+          <a:ln>
+            <a:noFill/>
+          </a:ln>
+          <a:effectLst/>
+        </p:spPr>
+        <p:style>
+          <a:lnRef idx="1">
+            <a:schemeClr val="accent1"/>
+          </a:lnRef>
+          <a:fillRef idx="3">
+            <a:schemeClr val="accent1"/>
+          </a:fillRef>
+          <a:effectRef idx="2">
+            <a:schemeClr val="accent1"/>
+          </a:effectRef>
+          <a:fontRef idx="minor">
+            <a:schemeClr val="lt1"/>
+          </a:fontRef>
+        </p:style>
+        <p:txBody>
+          <a:bodyPr rtlCol="0" anchor="ctr"/>
+          <a:lstStyle/>
+          <a:p>
+            <a:pPr algn="ctr"/>
+          </a:p>
+        </p:txBody>
+      </p:sp>
+      <p:sp>
+        <p:nvSpPr>
+          <p:cNvPr id="5" name="Rounded Rectangle 4"/>
+          <p:cNvSpPr/>
+          <p:nvPr/>
+        </p:nvSpPr>
+        <p:spPr>
+          <a:xfrm>
+            <a:off x="685800" y="1371600"/>
+            <a:ext cx="5349240" cy="2194560"/>
+          </a:xfrm>
+          <a:prstGeom prst="roundRect">
+            <a:avLst/>
+          </a:prstGeom>
+          <a:solidFill>
+            <a:srgbClr val="FEF2F2"/>
           </a:solidFill>
           <a:ln w="31750">
             <a:solidFill>
@@ -6895,7 +7719,7 @@
             <a:r>
               <a:rPr sz="1900" b="0">
                 <a:solidFill>
-                  <a:srgbClr val="B71C1C"/>
+                  <a:srgbClr val="991B1B"/>
                 </a:solidFill>
                 <a:latin typeface="Segoe UI"/>
               </a:rPr>
@@ -6906,7 +7730,7 @@
             <a:r>
               <a:rPr sz="1900" b="0">
                 <a:solidFill>
-                  <a:srgbClr val="B71C1C"/>
+                  <a:srgbClr val="991B1B"/>
                 </a:solidFill>
                 <a:latin typeface="Segoe UI"/>
               </a:rPr>
@@ -6917,7 +7741,7 @@
             <a:r>
               <a:rPr sz="1900" b="0">
                 <a:solidFill>
-                  <a:srgbClr val="B71C1C"/>
+                  <a:srgbClr val="991B1B"/>
                 </a:solidFill>
                 <a:latin typeface="Segoe UI"/>
               </a:rPr>
@@ -6928,7 +7752,7 @@
       </p:sp>
       <p:sp>
         <p:nvSpPr>
-          <p:cNvPr id="4" name="Rounded Rectangle 3"/>
+          <p:cNvPr id="6" name="Rounded Rectangle 5"/>
           <p:cNvSpPr/>
           <p:nvPr/>
         </p:nvSpPr>
@@ -6941,7 +7765,7 @@
             <a:avLst/>
           </a:prstGeom>
           <a:solidFill>
-            <a:srgbClr val="E8F5E9"/>
+            <a:srgbClr val="EAF6DB"/>
           </a:solidFill>
           <a:ln w="31750">
             <a:solidFill>
@@ -6972,7 +7796,7 @@
             <a:r>
               <a:rPr sz="1900" b="0">
                 <a:solidFill>
-                  <a:srgbClr val="1B5E20"/>
+                  <a:srgbClr val="0C3B1F"/>
                 </a:solidFill>
                 <a:latin typeface="Segoe UI"/>
               </a:rPr>
@@ -6983,7 +7807,7 @@
             <a:r>
               <a:rPr sz="1900" b="0">
                 <a:solidFill>
-                  <a:srgbClr val="1B5E20"/>
+                  <a:srgbClr val="0C3B1F"/>
                 </a:solidFill>
                 <a:latin typeface="Segoe UI"/>
               </a:rPr>
@@ -6994,7 +7818,7 @@
             <a:r>
               <a:rPr sz="1900" b="0">
                 <a:solidFill>
-                  <a:srgbClr val="1B5E20"/>
+                  <a:srgbClr val="0C3B1F"/>
                 </a:solidFill>
                 <a:latin typeface="Segoe UI"/>
               </a:rPr>
@@ -7005,7 +7829,7 @@
       </p:sp>
       <p:sp>
         <p:nvSpPr>
-          <p:cNvPr id="5" name="Rounded Rectangle 4"/>
+          <p:cNvPr id="7" name="Rounded Rectangle 6"/>
           <p:cNvSpPr/>
           <p:nvPr/>
         </p:nvSpPr>
@@ -7018,12 +7842,10 @@
             <a:avLst/>
           </a:prstGeom>
           <a:solidFill>
-            <a:srgbClr val="E8F5E9"/>
+            <a:srgbClr val="0C3B1F"/>
           </a:solidFill>
           <a:ln>
-            <a:solidFill>
-              <a:srgbClr val="E8F5E9"/>
-            </a:solidFill>
+            <a:noFill/>
           </a:ln>
           <a:effectLst/>
         </p:spPr>
@@ -7042,19 +7864,63 @@
           </a:fontRef>
         </p:style>
         <p:txBody>
-          <a:bodyPr rtlCol="0" anchor="ctr" wrap="square" lIns="228600" rIns="228600"/>
+          <a:bodyPr rtlCol="0" anchor="ctr" wrap="square" lIns="292608" rIns="228600"/>
           <a:lstStyle/>
           <a:p>
             <a:pPr algn="ctr"/>
             <a:r>
               <a:rPr sz="1800" b="0">
                 <a:solidFill>
-                  <a:srgbClr val="1B5E20"/>
+                  <a:srgbClr val="F2FFE0"/>
                 </a:solidFill>
                 <a:latin typeface="Segoe UI"/>
               </a:rPr>
               <a:t>Mesmo recurso, respostas diferentes: o portal vê contexto; o aplicativo vê só o essencial.</a:t>
             </a:r>
+          </a:p>
+        </p:txBody>
+      </p:sp>
+      <p:sp>
+        <p:nvSpPr>
+          <p:cNvPr id="8" name="Rectangle 7"/>
+          <p:cNvSpPr/>
+          <p:nvPr/>
+        </p:nvSpPr>
+        <p:spPr>
+          <a:xfrm>
+            <a:off x="685800" y="5532120"/>
+            <a:ext cx="100584" cy="868680"/>
+          </a:xfrm>
+          <a:prstGeom prst="rect">
+            <a:avLst/>
+          </a:prstGeom>
+          <a:solidFill>
+            <a:srgbClr val="A3E635"/>
+          </a:solidFill>
+          <a:ln>
+            <a:noFill/>
+          </a:ln>
+          <a:effectLst/>
+        </p:spPr>
+        <p:style>
+          <a:lnRef idx="1">
+            <a:schemeClr val="accent1"/>
+          </a:lnRef>
+          <a:fillRef idx="3">
+            <a:schemeClr val="accent1"/>
+          </a:fillRef>
+          <a:effectRef idx="2">
+            <a:schemeClr val="accent1"/>
+          </a:effectRef>
+          <a:fontRef idx="minor">
+            <a:schemeClr val="lt1"/>
+          </a:fontRef>
+        </p:style>
+        <p:txBody>
+          <a:bodyPr rtlCol="0" anchor="ctr"/>
+          <a:lstStyle/>
+          <a:p>
+            <a:pPr algn="ctr"/>
           </a:p>
         </p:txBody>
       </p:sp>
@@ -7072,7 +7938,7 @@
     <p:bg>
       <p:bgPr>
         <a:solidFill>
-          <a:srgbClr val="FBFBF6"/>
+          <a:srgbClr val="F7F9F0"/>
         </a:solidFill>
         <a:effectLst/>
       </p:bgPr>
@@ -7086,14 +7952,58 @@
       <p:grpSpPr/>
       <p:sp>
         <p:nvSpPr>
-          <p:cNvPr id="2" name="TextBox 1"/>
+          <p:cNvPr id="2" name="Rectangle 1"/>
+          <p:cNvSpPr/>
+          <p:nvPr/>
+        </p:nvSpPr>
+        <p:spPr>
+          <a:xfrm>
+            <a:off x="0" y="0"/>
+            <a:ext cx="12191695" cy="73152"/>
+          </a:xfrm>
+          <a:prstGeom prst="rect">
+            <a:avLst/>
+          </a:prstGeom>
+          <a:solidFill>
+            <a:srgbClr val="1E6B33"/>
+          </a:solidFill>
+          <a:ln>
+            <a:noFill/>
+          </a:ln>
+          <a:effectLst/>
+        </p:spPr>
+        <p:style>
+          <a:lnRef idx="1">
+            <a:schemeClr val="accent1"/>
+          </a:lnRef>
+          <a:fillRef idx="3">
+            <a:schemeClr val="accent1"/>
+          </a:fillRef>
+          <a:effectRef idx="2">
+            <a:schemeClr val="accent1"/>
+          </a:effectRef>
+          <a:fontRef idx="minor">
+            <a:schemeClr val="lt1"/>
+          </a:fontRef>
+        </p:style>
+        <p:txBody>
+          <a:bodyPr rtlCol="0" anchor="ctr"/>
+          <a:lstStyle/>
+          <a:p>
+            <a:pPr algn="ctr"/>
+          </a:p>
+        </p:txBody>
+      </p:sp>
+      <p:sp>
+        <p:nvSpPr>
+          <p:cNvPr id="3" name="TextBox 2"/>
           <p:cNvSpPr txBox="1"/>
           <p:nvPr/>
         </p:nvSpPr>
         <p:spPr>
           <a:xfrm>
-            <a:off x="685800" y="411480"/>
-            <a:ext cx="10881360" cy="914400"/>
+            <a:off x="685800" y="384048"/>
+            <a:ext cx="10881360" cy="822960"/>
           </a:xfrm>
           <a:prstGeom prst="rect">
             <a:avLst/>
@@ -7108,11 +8018,11 @@
           <a:p>
             <a:pPr algn="l"/>
             <a:r>
-              <a:rPr sz="3600" b="1">
-                <a:solidFill>
-                  <a:srgbClr val="1B5E20"/>
-                </a:solidFill>
-                <a:latin typeface="Segoe UI"/>
+              <a:rPr sz="3800" b="1">
+                <a:solidFill>
+                  <a:srgbClr val="0C3B1F"/>
+                </a:solidFill>
+                <a:latin typeface="Bahnschrift"/>
               </a:rPr>
               <a:t>Um banco por serviço — e o outbox</a:t>
             </a:r>
@@ -7121,13 +8031,57 @@
       </p:sp>
       <p:sp>
         <p:nvSpPr>
-          <p:cNvPr id="3" name="TextBox 2"/>
+          <p:cNvPr id="4" name="Rounded Rectangle 3"/>
+          <p:cNvSpPr/>
+          <p:nvPr/>
+        </p:nvSpPr>
+        <p:spPr>
+          <a:xfrm>
+            <a:off x="713232" y="1152144"/>
+            <a:ext cx="960120" cy="68580"/>
+          </a:xfrm>
+          <a:prstGeom prst="roundRect">
+            <a:avLst/>
+          </a:prstGeom>
+          <a:solidFill>
+            <a:srgbClr val="A3E635"/>
+          </a:solidFill>
+          <a:ln>
+            <a:noFill/>
+          </a:ln>
+          <a:effectLst/>
+        </p:spPr>
+        <p:style>
+          <a:lnRef idx="1">
+            <a:schemeClr val="accent1"/>
+          </a:lnRef>
+          <a:fillRef idx="3">
+            <a:schemeClr val="accent1"/>
+          </a:fillRef>
+          <a:effectRef idx="2">
+            <a:schemeClr val="accent1"/>
+          </a:effectRef>
+          <a:fontRef idx="minor">
+            <a:schemeClr val="lt1"/>
+          </a:fontRef>
+        </p:style>
+        <p:txBody>
+          <a:bodyPr rtlCol="0" anchor="ctr"/>
+          <a:lstStyle/>
+          <a:p>
+            <a:pPr algn="ctr"/>
+          </a:p>
+        </p:txBody>
+      </p:sp>
+      <p:sp>
+        <p:nvSpPr>
+          <p:cNvPr id="5" name="TextBox 4"/>
           <p:cNvSpPr txBox="1"/>
           <p:nvPr/>
         </p:nvSpPr>
         <p:spPr>
           <a:xfrm>
-            <a:off x="685800" y="1463040"/>
+            <a:off x="685800" y="1481328"/>
             <a:ext cx="10881360" cy="3840480"/>
           </a:xfrm>
           <a:prstGeom prst="rect">
@@ -7152,7 +8106,7 @@
             <a:r>
               <a:rPr sz="2200" b="1">
                 <a:solidFill>
-                  <a:srgbClr val="1B5E20"/>
+                  <a:srgbClr val="0C3B1F"/>
                 </a:solidFill>
                 <a:latin typeface="Segoe UI"/>
               </a:rPr>
@@ -7161,7 +8115,7 @@
             <a:r>
               <a:rPr sz="2200" b="0">
                 <a:solidFill>
-                  <a:srgbClr val="1F2D33"/>
+                  <a:srgbClr val="0F1B14"/>
                 </a:solidFill>
                 <a:latin typeface="Segoe UI"/>
               </a:rPr>
@@ -7170,7 +8124,7 @@
             <a:r>
               <a:rPr sz="2200" b="1">
                 <a:solidFill>
-                  <a:srgbClr val="1B5E20"/>
+                  <a:srgbClr val="0C3B1F"/>
                 </a:solidFill>
                 <a:latin typeface="Segoe UI"/>
               </a:rPr>
@@ -7179,7 +8133,7 @@
             <a:r>
               <a:rPr sz="2200" b="0">
                 <a:solidFill>
-                  <a:srgbClr val="1F2D33"/>
+                  <a:srgbClr val="0F1B14"/>
                 </a:solidFill>
                 <a:latin typeface="Segoe UI"/>
               </a:rPr>
@@ -7188,7 +8142,7 @@
             <a:r>
               <a:rPr sz="2200" b="1">
                 <a:solidFill>
-                  <a:srgbClr val="1B5E20"/>
+                  <a:srgbClr val="0C3B1F"/>
                 </a:solidFill>
                 <a:latin typeface="Segoe UI"/>
               </a:rPr>
@@ -7207,7 +8161,7 @@
             <a:r>
               <a:rPr sz="2200" b="1">
                 <a:solidFill>
-                  <a:srgbClr val="1B5E20"/>
+                  <a:srgbClr val="0C3B1F"/>
                 </a:solidFill>
                 <a:latin typeface="Segoe UI"/>
               </a:rPr>
@@ -7216,7 +8170,7 @@
             <a:r>
               <a:rPr sz="2200" b="0">
                 <a:solidFill>
-                  <a:srgbClr val="1F2D33"/>
+                  <a:srgbClr val="0F1B14"/>
                 </a:solidFill>
                 <a:latin typeface="Segoe UI"/>
               </a:rPr>
@@ -7225,7 +8179,7 @@
             <a:r>
               <a:rPr sz="2200" b="1">
                 <a:solidFill>
-                  <a:srgbClr val="1B5E20"/>
+                  <a:srgbClr val="0C3B1F"/>
                 </a:solidFill>
                 <a:latin typeface="Segoe UI"/>
               </a:rPr>
@@ -7234,7 +8188,7 @@
             <a:r>
               <a:rPr sz="2200" b="0">
                 <a:solidFill>
-                  <a:srgbClr val="1F2D33"/>
+                  <a:srgbClr val="0F1B14"/>
                 </a:solidFill>
                 <a:latin typeface="Segoe UI"/>
               </a:rPr>
@@ -7253,7 +8207,7 @@
             <a:r>
               <a:rPr sz="2200" b="1">
                 <a:solidFill>
-                  <a:srgbClr val="1B5E20"/>
+                  <a:srgbClr val="0C3B1F"/>
                 </a:solidFill>
                 <a:latin typeface="Segoe UI"/>
               </a:rPr>
@@ -7262,7 +8216,7 @@
             <a:r>
               <a:rPr sz="2200" b="0">
                 <a:solidFill>
-                  <a:srgbClr val="1F2D33"/>
+                  <a:srgbClr val="0F1B14"/>
                 </a:solidFill>
                 <a:latin typeface="Segoe UI"/>
               </a:rPr>
@@ -7281,7 +8235,7 @@
             <a:r>
               <a:rPr sz="2200" b="1">
                 <a:solidFill>
-                  <a:srgbClr val="1B5E20"/>
+                  <a:srgbClr val="0C3B1F"/>
                 </a:solidFill>
                 <a:latin typeface="Segoe UI"/>
               </a:rPr>
@@ -7290,7 +8244,7 @@
             <a:r>
               <a:rPr sz="2200" b="1">
                 <a:solidFill>
-                  <a:srgbClr val="1B5E20"/>
+                  <a:srgbClr val="0C3B1F"/>
                 </a:solidFill>
                 <a:latin typeface="Segoe UI"/>
               </a:rPr>
@@ -7299,7 +8253,7 @@
             <a:r>
               <a:rPr sz="2200" b="0">
                 <a:solidFill>
-                  <a:srgbClr val="1F2D33"/>
+                  <a:srgbClr val="0F1B14"/>
                 </a:solidFill>
                 <a:latin typeface="Segoe UI"/>
               </a:rPr>
@@ -7318,7 +8272,7 @@
             <a:r>
               <a:rPr sz="2200" b="1">
                 <a:solidFill>
-                  <a:srgbClr val="1B5E20"/>
+                  <a:srgbClr val="0C3B1F"/>
                 </a:solidFill>
                 <a:latin typeface="Segoe UI"/>
               </a:rPr>
@@ -7327,7 +8281,7 @@
             <a:r>
               <a:rPr sz="2200" b="0">
                 <a:solidFill>
-                  <a:srgbClr val="1F2D33"/>
+                  <a:srgbClr val="0F1B14"/>
                 </a:solidFill>
                 <a:latin typeface="Segoe UI"/>
               </a:rPr>
@@ -7338,7 +8292,7 @@
       </p:sp>
       <p:sp>
         <p:nvSpPr>
-          <p:cNvPr id="4" name="Rounded Rectangle 3"/>
+          <p:cNvPr id="6" name="Rounded Rectangle 5"/>
           <p:cNvSpPr/>
           <p:nvPr/>
         </p:nvSpPr>
@@ -7351,12 +8305,10 @@
             <a:avLst/>
           </a:prstGeom>
           <a:solidFill>
-            <a:srgbClr val="E8F5E9"/>
+            <a:srgbClr val="0C3B1F"/>
           </a:solidFill>
           <a:ln>
-            <a:solidFill>
-              <a:srgbClr val="E8F5E9"/>
-            </a:solidFill>
+            <a:noFill/>
           </a:ln>
           <a:effectLst/>
         </p:spPr>
@@ -7375,19 +8327,63 @@
           </a:fontRef>
         </p:style>
         <p:txBody>
-          <a:bodyPr rtlCol="0" anchor="ctr" wrap="square" lIns="228600" rIns="228600"/>
+          <a:bodyPr rtlCol="0" anchor="ctr" wrap="square" lIns="292608" rIns="228600"/>
           <a:lstStyle/>
           <a:p>
             <a:pPr algn="ctr"/>
             <a:r>
               <a:rPr sz="1800" b="0">
                 <a:solidFill>
-                  <a:srgbClr val="1B5E20"/>
+                  <a:srgbClr val="F2FFE0"/>
                 </a:solidFill>
                 <a:latin typeface="Segoe UI"/>
               </a:rPr>
               <a:t>Não usamos transação distribuída: outbox resolve o dual write e a inbox garante idempotência.</a:t>
             </a:r>
+          </a:p>
+        </p:txBody>
+      </p:sp>
+      <p:sp>
+        <p:nvSpPr>
+          <p:cNvPr id="7" name="Rectangle 6"/>
+          <p:cNvSpPr/>
+          <p:nvPr/>
+        </p:nvSpPr>
+        <p:spPr>
+          <a:xfrm>
+            <a:off x="685800" y="5532120"/>
+            <a:ext cx="100584" cy="868680"/>
+          </a:xfrm>
+          <a:prstGeom prst="rect">
+            <a:avLst/>
+          </a:prstGeom>
+          <a:solidFill>
+            <a:srgbClr val="A3E635"/>
+          </a:solidFill>
+          <a:ln>
+            <a:noFill/>
+          </a:ln>
+          <a:effectLst/>
+        </p:spPr>
+        <p:style>
+          <a:lnRef idx="1">
+            <a:schemeClr val="accent1"/>
+          </a:lnRef>
+          <a:fillRef idx="3">
+            <a:schemeClr val="accent1"/>
+          </a:fillRef>
+          <a:effectRef idx="2">
+            <a:schemeClr val="accent1"/>
+          </a:effectRef>
+          <a:fontRef idx="minor">
+            <a:schemeClr val="lt1"/>
+          </a:fontRef>
+        </p:style>
+        <p:txBody>
+          <a:bodyPr rtlCol="0" anchor="ctr"/>
+          <a:lstStyle/>
+          <a:p>
+            <a:pPr algn="ctr"/>
           </a:p>
         </p:txBody>
       </p:sp>
@@ -7405,7 +8401,7 @@
     <p:bg>
       <p:bgPr>
         <a:solidFill>
-          <a:srgbClr val="FBFBF6"/>
+          <a:srgbClr val="F7F9F0"/>
         </a:solidFill>
         <a:effectLst/>
       </p:bgPr>
@@ -7419,14 +8415,58 @@
       <p:grpSpPr/>
       <p:sp>
         <p:nvSpPr>
-          <p:cNvPr id="2" name="TextBox 1"/>
+          <p:cNvPr id="2" name="Rectangle 1"/>
+          <p:cNvSpPr/>
+          <p:nvPr/>
+        </p:nvSpPr>
+        <p:spPr>
+          <a:xfrm>
+            <a:off x="0" y="0"/>
+            <a:ext cx="12191695" cy="73152"/>
+          </a:xfrm>
+          <a:prstGeom prst="rect">
+            <a:avLst/>
+          </a:prstGeom>
+          <a:solidFill>
+            <a:srgbClr val="1E6B33"/>
+          </a:solidFill>
+          <a:ln>
+            <a:noFill/>
+          </a:ln>
+          <a:effectLst/>
+        </p:spPr>
+        <p:style>
+          <a:lnRef idx="1">
+            <a:schemeClr val="accent1"/>
+          </a:lnRef>
+          <a:fillRef idx="3">
+            <a:schemeClr val="accent1"/>
+          </a:fillRef>
+          <a:effectRef idx="2">
+            <a:schemeClr val="accent1"/>
+          </a:effectRef>
+          <a:fontRef idx="minor">
+            <a:schemeClr val="lt1"/>
+          </a:fontRef>
+        </p:style>
+        <p:txBody>
+          <a:bodyPr rtlCol="0" anchor="ctr"/>
+          <a:lstStyle/>
+          <a:p>
+            <a:pPr algn="ctr"/>
+          </a:p>
+        </p:txBody>
+      </p:sp>
+      <p:sp>
+        <p:nvSpPr>
+          <p:cNvPr id="3" name="TextBox 2"/>
           <p:cNvSpPr txBox="1"/>
           <p:nvPr/>
         </p:nvSpPr>
         <p:spPr>
           <a:xfrm>
-            <a:off x="685800" y="411480"/>
-            <a:ext cx="10881360" cy="914400"/>
+            <a:off x="685800" y="384048"/>
+            <a:ext cx="10881360" cy="822960"/>
           </a:xfrm>
           <a:prstGeom prst="rect">
             <a:avLst/>
@@ -7441,11 +8481,11 @@
           <a:p>
             <a:pPr algn="l"/>
             <a:r>
-              <a:rPr sz="3600" b="1">
-                <a:solidFill>
-                  <a:srgbClr val="1B5E20"/>
-                </a:solidFill>
-                <a:latin typeface="Segoe UI"/>
+              <a:rPr sz="3800" b="1">
+                <a:solidFill>
+                  <a:srgbClr val="0C3B1F"/>
+                </a:solidFill>
+                <a:latin typeface="Bahnschrift"/>
               </a:rPr>
               <a:t>SAGA: confirmar a compra</a:t>
             </a:r>
@@ -7454,13 +8494,57 @@
       </p:sp>
       <p:sp>
         <p:nvSpPr>
-          <p:cNvPr id="3" name="TextBox 2"/>
+          <p:cNvPr id="4" name="Rounded Rectangle 3"/>
+          <p:cNvSpPr/>
+          <p:nvPr/>
+        </p:nvSpPr>
+        <p:spPr>
+          <a:xfrm>
+            <a:off x="713232" y="1152144"/>
+            <a:ext cx="960120" cy="68580"/>
+          </a:xfrm>
+          <a:prstGeom prst="roundRect">
+            <a:avLst/>
+          </a:prstGeom>
+          <a:solidFill>
+            <a:srgbClr val="A3E635"/>
+          </a:solidFill>
+          <a:ln>
+            <a:noFill/>
+          </a:ln>
+          <a:effectLst/>
+        </p:spPr>
+        <p:style>
+          <a:lnRef idx="1">
+            <a:schemeClr val="accent1"/>
+          </a:lnRef>
+          <a:fillRef idx="3">
+            <a:schemeClr val="accent1"/>
+          </a:fillRef>
+          <a:effectRef idx="2">
+            <a:schemeClr val="accent1"/>
+          </a:effectRef>
+          <a:fontRef idx="minor">
+            <a:schemeClr val="lt1"/>
+          </a:fontRef>
+        </p:style>
+        <p:txBody>
+          <a:bodyPr rtlCol="0" anchor="ctr"/>
+          <a:lstStyle/>
+          <a:p>
+            <a:pPr algn="ctr"/>
+          </a:p>
+        </p:txBody>
+      </p:sp>
+      <p:sp>
+        <p:nvSpPr>
+          <p:cNvPr id="5" name="TextBox 4"/>
           <p:cNvSpPr txBox="1"/>
           <p:nvPr/>
         </p:nvSpPr>
         <p:spPr>
           <a:xfrm>
-            <a:off x="685800" y="1463040"/>
+            <a:off x="685800" y="1481328"/>
             <a:ext cx="10881360" cy="3977639"/>
           </a:xfrm>
           <a:prstGeom prst="rect">
@@ -7485,7 +8569,7 @@
             <a:r>
               <a:rPr sz="2400" b="1">
                 <a:solidFill>
-                  <a:srgbClr val="1B5E20"/>
+                  <a:srgbClr val="0C3B1F"/>
                 </a:solidFill>
                 <a:latin typeface="Segoe UI"/>
               </a:rPr>
@@ -7494,7 +8578,7 @@
             <a:r>
               <a:rPr sz="2400" b="1">
                 <a:solidFill>
-                  <a:srgbClr val="1B5E20"/>
+                  <a:srgbClr val="0C3B1F"/>
                 </a:solidFill>
                 <a:latin typeface="Segoe UI"/>
               </a:rPr>
@@ -7503,7 +8587,7 @@
             <a:r>
               <a:rPr sz="2400" b="0">
                 <a:solidFill>
-                  <a:srgbClr val="1F2D33"/>
+                  <a:srgbClr val="0F1B14"/>
                 </a:solidFill>
                 <a:latin typeface="Segoe UI"/>
               </a:rPr>
@@ -7522,7 +8606,7 @@
             <a:r>
               <a:rPr sz="2400" b="1">
                 <a:solidFill>
-                  <a:srgbClr val="1B5E20"/>
+                  <a:srgbClr val="0C3B1F"/>
                 </a:solidFill>
                 <a:latin typeface="Segoe UI"/>
               </a:rPr>
@@ -7531,7 +8615,7 @@
             <a:r>
               <a:rPr sz="2400" b="0">
                 <a:solidFill>
-                  <a:srgbClr val="1F2D33"/>
+                  <a:srgbClr val="0F1B14"/>
                 </a:solidFill>
                 <a:latin typeface="Segoe UI"/>
               </a:rPr>
@@ -7540,7 +8624,7 @@
             <a:r>
               <a:rPr sz="2400" b="1">
                 <a:solidFill>
-                  <a:srgbClr val="1B5E20"/>
+                  <a:srgbClr val="0C3B1F"/>
                 </a:solidFill>
                 <a:latin typeface="Segoe UI"/>
               </a:rPr>
@@ -7559,7 +8643,7 @@
             <a:r>
               <a:rPr sz="2400" b="1">
                 <a:solidFill>
-                  <a:srgbClr val="1B5E20"/>
+                  <a:srgbClr val="0C3B1F"/>
                 </a:solidFill>
                 <a:latin typeface="Segoe UI"/>
               </a:rPr>
@@ -7568,7 +8652,7 @@
             <a:r>
               <a:rPr sz="2400" b="0">
                 <a:solidFill>
-                  <a:srgbClr val="1F2D33"/>
+                  <a:srgbClr val="0F1B14"/>
                 </a:solidFill>
                 <a:latin typeface="Segoe UI"/>
               </a:rPr>
@@ -7577,7 +8661,7 @@
             <a:r>
               <a:rPr sz="2400" b="1">
                 <a:solidFill>
-                  <a:srgbClr val="1B5E20"/>
+                  <a:srgbClr val="0C3B1F"/>
                 </a:solidFill>
                 <a:latin typeface="Segoe UI"/>
               </a:rPr>
@@ -7586,7 +8670,7 @@
             <a:r>
               <a:rPr sz="2400" b="0">
                 <a:solidFill>
-                  <a:srgbClr val="1F2D33"/>
+                  <a:srgbClr val="0F1B14"/>
                 </a:solidFill>
                 <a:latin typeface="Segoe UI"/>
               </a:rPr>
@@ -7595,7 +8679,7 @@
             <a:r>
               <a:rPr sz="2400" b="1">
                 <a:solidFill>
-                  <a:srgbClr val="1B5E20"/>
+                  <a:srgbClr val="0C3B1F"/>
                 </a:solidFill>
                 <a:latin typeface="Segoe UI"/>
               </a:rPr>
@@ -7604,7 +8688,7 @@
             <a:r>
               <a:rPr sz="2400" b="0">
                 <a:solidFill>
-                  <a:srgbClr val="1F2D33"/>
+                  <a:srgbClr val="0F1B14"/>
                 </a:solidFill>
                 <a:latin typeface="Segoe UI"/>
               </a:rPr>
@@ -7613,7 +8697,7 @@
             <a:r>
               <a:rPr sz="2400" b="1">
                 <a:solidFill>
-                  <a:srgbClr val="1B5E20"/>
+                  <a:srgbClr val="0C3B1F"/>
                 </a:solidFill>
                 <a:latin typeface="Segoe UI"/>
               </a:rPr>
@@ -7622,7 +8706,7 @@
             <a:r>
               <a:rPr sz="2400" b="0">
                 <a:solidFill>
-                  <a:srgbClr val="1F2D33"/>
+                  <a:srgbClr val="0F1B14"/>
                 </a:solidFill>
                 <a:latin typeface="Segoe UI"/>
               </a:rPr>
@@ -7641,7 +8725,7 @@
             <a:r>
               <a:rPr sz="2400" b="1">
                 <a:solidFill>
-                  <a:srgbClr val="1B5E20"/>
+                  <a:srgbClr val="0C3B1F"/>
                 </a:solidFill>
                 <a:latin typeface="Segoe UI"/>
               </a:rPr>
@@ -7650,7 +8734,7 @@
             <a:r>
               <a:rPr sz="2400" b="0">
                 <a:solidFill>
-                  <a:srgbClr val="1F2D33"/>
+                  <a:srgbClr val="0F1B14"/>
                 </a:solidFill>
                 <a:latin typeface="Segoe UI"/>
               </a:rPr>
@@ -7659,7 +8743,7 @@
             <a:r>
               <a:rPr sz="2400" b="1">
                 <a:solidFill>
-                  <a:srgbClr val="1B5E20"/>
+                  <a:srgbClr val="0C3B1F"/>
                 </a:solidFill>
                 <a:latin typeface="Segoe UI"/>
               </a:rPr>
@@ -7668,7 +8752,7 @@
             <a:r>
               <a:rPr sz="2400" b="0">
                 <a:solidFill>
-                  <a:srgbClr val="1F2D33"/>
+                  <a:srgbClr val="0F1B14"/>
                 </a:solidFill>
                 <a:latin typeface="Segoe UI"/>
               </a:rPr>
@@ -7677,7 +8761,7 @@
             <a:r>
               <a:rPr sz="2400" b="1">
                 <a:solidFill>
-                  <a:srgbClr val="1B5E20"/>
+                  <a:srgbClr val="0C3B1F"/>
                 </a:solidFill>
                 <a:latin typeface="Segoe UI"/>
               </a:rPr>
@@ -7686,7 +8770,7 @@
             <a:r>
               <a:rPr sz="2400" b="0">
                 <a:solidFill>
-                  <a:srgbClr val="1F2D33"/>
+                  <a:srgbClr val="0F1B14"/>
                 </a:solidFill>
                 <a:latin typeface="Segoe UI"/>
               </a:rPr>
@@ -7697,7 +8781,7 @@
       </p:sp>
       <p:sp>
         <p:nvSpPr>
-          <p:cNvPr id="4" name="Rounded Rectangle 3"/>
+          <p:cNvPr id="6" name="Rounded Rectangle 5"/>
           <p:cNvSpPr/>
           <p:nvPr/>
         </p:nvSpPr>
@@ -7710,12 +8794,10 @@
             <a:avLst/>
           </a:prstGeom>
           <a:solidFill>
-            <a:srgbClr val="E8F5E9"/>
+            <a:srgbClr val="0C3B1F"/>
           </a:solidFill>
           <a:ln>
-            <a:solidFill>
-              <a:srgbClr val="E8F5E9"/>
-            </a:solidFill>
+            <a:noFill/>
           </a:ln>
           <a:effectLst/>
         </p:spPr>
@@ -7734,19 +8816,63 @@
           </a:fontRef>
         </p:style>
         <p:txBody>
-          <a:bodyPr rtlCol="0" anchor="ctr" wrap="square" lIns="228600" rIns="228600"/>
+          <a:bodyPr rtlCol="0" anchor="ctr" wrap="square" lIns="292608" rIns="228600"/>
           <a:lstStyle/>
           <a:p>
             <a:pPr algn="ctr"/>
             <a:r>
               <a:rPr sz="1800" b="0">
                 <a:solidFill>
-                  <a:srgbClr val="1B5E20"/>
+                  <a:srgbClr val="F2FFE0"/>
                 </a:solidFill>
                 <a:latin typeface="Segoe UI"/>
               </a:rPr>
               <a:t>Quatro serviços, quatro passos e três compensações: a compra só cancela depois de desfazer tudo.</a:t>
             </a:r>
+          </a:p>
+        </p:txBody>
+      </p:sp>
+      <p:sp>
+        <p:nvSpPr>
+          <p:cNvPr id="7" name="Rectangle 6"/>
+          <p:cNvSpPr/>
+          <p:nvPr/>
+        </p:nvSpPr>
+        <p:spPr>
+          <a:xfrm>
+            <a:off x="685800" y="5532120"/>
+            <a:ext cx="100584" cy="868680"/>
+          </a:xfrm>
+          <a:prstGeom prst="rect">
+            <a:avLst/>
+          </a:prstGeom>
+          <a:solidFill>
+            <a:srgbClr val="A3E635"/>
+          </a:solidFill>
+          <a:ln>
+            <a:noFill/>
+          </a:ln>
+          <a:effectLst/>
+        </p:spPr>
+        <p:style>
+          <a:lnRef idx="1">
+            <a:schemeClr val="accent1"/>
+          </a:lnRef>
+          <a:fillRef idx="3">
+            <a:schemeClr val="accent1"/>
+          </a:fillRef>
+          <a:effectRef idx="2">
+            <a:schemeClr val="accent1"/>
+          </a:effectRef>
+          <a:fontRef idx="minor">
+            <a:schemeClr val="lt1"/>
+          </a:fontRef>
+        </p:style>
+        <p:txBody>
+          <a:bodyPr rtlCol="0" anchor="ctr"/>
+          <a:lstStyle/>
+          <a:p>
+            <a:pPr algn="ctr"/>
           </a:p>
         </p:txBody>
       </p:sp>
@@ -7764,7 +8890,7 @@
     <p:bg>
       <p:bgPr>
         <a:solidFill>
-          <a:srgbClr val="FBFBF6"/>
+          <a:srgbClr val="F7F9F0"/>
         </a:solidFill>
         <a:effectLst/>
       </p:bgPr>
@@ -7778,14 +8904,58 @@
       <p:grpSpPr/>
       <p:sp>
         <p:nvSpPr>
-          <p:cNvPr id="2" name="TextBox 1"/>
+          <p:cNvPr id="2" name="Rectangle 1"/>
+          <p:cNvSpPr/>
+          <p:nvPr/>
+        </p:nvSpPr>
+        <p:spPr>
+          <a:xfrm>
+            <a:off x="0" y="0"/>
+            <a:ext cx="12191695" cy="73152"/>
+          </a:xfrm>
+          <a:prstGeom prst="rect">
+            <a:avLst/>
+          </a:prstGeom>
+          <a:solidFill>
+            <a:srgbClr val="1E6B33"/>
+          </a:solidFill>
+          <a:ln>
+            <a:noFill/>
+          </a:ln>
+          <a:effectLst/>
+        </p:spPr>
+        <p:style>
+          <a:lnRef idx="1">
+            <a:schemeClr val="accent1"/>
+          </a:lnRef>
+          <a:fillRef idx="3">
+            <a:schemeClr val="accent1"/>
+          </a:fillRef>
+          <a:effectRef idx="2">
+            <a:schemeClr val="accent1"/>
+          </a:effectRef>
+          <a:fontRef idx="minor">
+            <a:schemeClr val="lt1"/>
+          </a:fontRef>
+        </p:style>
+        <p:txBody>
+          <a:bodyPr rtlCol="0" anchor="ctr"/>
+          <a:lstStyle/>
+          <a:p>
+            <a:pPr algn="ctr"/>
+          </a:p>
+        </p:txBody>
+      </p:sp>
+      <p:sp>
+        <p:nvSpPr>
+          <p:cNvPr id="3" name="TextBox 2"/>
           <p:cNvSpPr txBox="1"/>
           <p:nvPr/>
         </p:nvSpPr>
         <p:spPr>
           <a:xfrm>
-            <a:off x="685800" y="411480"/>
-            <a:ext cx="10881360" cy="914400"/>
+            <a:off x="685800" y="384048"/>
+            <a:ext cx="10881360" cy="822960"/>
           </a:xfrm>
           <a:prstGeom prst="rect">
             <a:avLst/>
@@ -7800,11 +8970,11 @@
           <a:p>
             <a:pPr algn="l"/>
             <a:r>
-              <a:rPr sz="3600" b="1">
-                <a:solidFill>
-                  <a:srgbClr val="1B5E20"/>
-                </a:solidFill>
-                <a:latin typeface="Segoe UI"/>
+              <a:rPr sz="3800" b="1">
+                <a:solidFill>
+                  <a:srgbClr val="0C3B1F"/>
+                </a:solidFill>
+                <a:latin typeface="Bahnschrift"/>
               </a:rPr>
               <a:t>CQRS em Compras</a:t>
             </a:r>
@@ -7813,20 +8983,64 @@
       </p:sp>
       <p:sp>
         <p:nvSpPr>
-          <p:cNvPr id="3" name="Rounded Rectangle 2"/>
+          <p:cNvPr id="4" name="Rounded Rectangle 3"/>
           <p:cNvSpPr/>
           <p:nvPr/>
         </p:nvSpPr>
         <p:spPr>
           <a:xfrm>
-            <a:off x="685800" y="1371600"/>
-            <a:ext cx="5349240" cy="2194560"/>
+            <a:off x="713232" y="1152144"/>
+            <a:ext cx="960120" cy="68580"/>
           </a:xfrm>
           <a:prstGeom prst="roundRect">
             <a:avLst/>
           </a:prstGeom>
           <a:solidFill>
-            <a:srgbClr val="FFEBEE"/>
+            <a:srgbClr val="A3E635"/>
+          </a:solidFill>
+          <a:ln>
+            <a:noFill/>
+          </a:ln>
+          <a:effectLst/>
+        </p:spPr>
+        <p:style>
+          <a:lnRef idx="1">
+            <a:schemeClr val="accent1"/>
+          </a:lnRef>
+          <a:fillRef idx="3">
+            <a:schemeClr val="accent1"/>
+          </a:fillRef>
+          <a:effectRef idx="2">
+            <a:schemeClr val="accent1"/>
+          </a:effectRef>
+          <a:fontRef idx="minor">
+            <a:schemeClr val="lt1"/>
+          </a:fontRef>
+        </p:style>
+        <p:txBody>
+          <a:bodyPr rtlCol="0" anchor="ctr"/>
+          <a:lstStyle/>
+          <a:p>
+            <a:pPr algn="ctr"/>
+          </a:p>
+        </p:txBody>
+      </p:sp>
+      <p:sp>
+        <p:nvSpPr>
+          <p:cNvPr id="5" name="Rounded Rectangle 4"/>
+          <p:cNvSpPr/>
+          <p:nvPr/>
+        </p:nvSpPr>
+        <p:spPr>
+          <a:xfrm>
+            <a:off x="685800" y="1371600"/>
+            <a:ext cx="5349240" cy="2194560"/>
+          </a:xfrm>
+          <a:prstGeom prst="roundRect">
+            <a:avLst/>
+          </a:prstGeom>
+          <a:solidFill>
+            <a:srgbClr val="FEF2F2"/>
           </a:solidFill>
           <a:ln w="31750">
             <a:solidFill>
@@ -7857,7 +9071,7 @@
             <a:r>
               <a:rPr sz="2000" b="0">
                 <a:solidFill>
-                  <a:srgbClr val="B71C1C"/>
+                  <a:srgbClr val="991B1B"/>
                 </a:solidFill>
                 <a:latin typeface="Segoe UI"/>
               </a:rPr>
@@ -7868,7 +9082,7 @@
             <a:r>
               <a:rPr sz="2000" b="0">
                 <a:solidFill>
-                  <a:srgbClr val="B71C1C"/>
+                  <a:srgbClr val="991B1B"/>
                 </a:solidFill>
                 <a:latin typeface="Segoe UI"/>
               </a:rPr>
@@ -7879,7 +9093,7 @@
       </p:sp>
       <p:sp>
         <p:nvSpPr>
-          <p:cNvPr id="4" name="Rounded Rectangle 3"/>
+          <p:cNvPr id="6" name="Rounded Rectangle 5"/>
           <p:cNvSpPr/>
           <p:nvPr/>
         </p:nvSpPr>
@@ -7892,7 +9106,7 @@
             <a:avLst/>
           </a:prstGeom>
           <a:solidFill>
-            <a:srgbClr val="E8F5E9"/>
+            <a:srgbClr val="EAF6DB"/>
           </a:solidFill>
           <a:ln w="31750">
             <a:solidFill>
@@ -7923,7 +9137,7 @@
             <a:r>
               <a:rPr sz="2000" b="0">
                 <a:solidFill>
-                  <a:srgbClr val="1B5E20"/>
+                  <a:srgbClr val="0C3B1F"/>
                 </a:solidFill>
                 <a:latin typeface="Segoe UI"/>
               </a:rPr>
@@ -7934,7 +9148,7 @@
             <a:r>
               <a:rPr sz="2000" b="0">
                 <a:solidFill>
-                  <a:srgbClr val="1B5E20"/>
+                  <a:srgbClr val="0C3B1F"/>
                 </a:solidFill>
                 <a:latin typeface="Segoe UI"/>
               </a:rPr>
@@ -7945,7 +9159,7 @@
       </p:sp>
       <p:sp>
         <p:nvSpPr>
-          <p:cNvPr id="5" name="TextBox 4"/>
+          <p:cNvPr id="7" name="TextBox 6"/>
           <p:cNvSpPr txBox="1"/>
           <p:nvPr/>
         </p:nvSpPr>
@@ -7976,7 +9190,7 @@
             <a:r>
               <a:rPr sz="2200" b="1">
                 <a:solidFill>
-                  <a:srgbClr val="1B5E20"/>
+                  <a:srgbClr val="0C3B1F"/>
                 </a:solidFill>
                 <a:latin typeface="Segoe UI"/>
               </a:rPr>
@@ -7985,7 +9199,7 @@
             <a:r>
               <a:rPr sz="2200" b="0">
                 <a:solidFill>
-                  <a:srgbClr val="1F2D33"/>
+                  <a:srgbClr val="0F1B14"/>
                 </a:solidFill>
                 <a:latin typeface="Segoe UI"/>
               </a:rPr>
@@ -7994,7 +9208,7 @@
             <a:r>
               <a:rPr sz="2200" b="1">
                 <a:solidFill>
-                  <a:srgbClr val="1B5E20"/>
+                  <a:srgbClr val="0C3B1F"/>
                 </a:solidFill>
                 <a:latin typeface="Segoe UI"/>
               </a:rPr>
@@ -8003,7 +9217,7 @@
             <a:r>
               <a:rPr sz="2200" b="0">
                 <a:solidFill>
-                  <a:srgbClr val="1F2D33"/>
+                  <a:srgbClr val="0F1B14"/>
                 </a:solidFill>
                 <a:latin typeface="Segoe UI"/>
               </a:rPr>
@@ -8022,7 +9236,7 @@
             <a:r>
               <a:rPr sz="2200" b="1">
                 <a:solidFill>
-                  <a:srgbClr val="1B5E20"/>
+                  <a:srgbClr val="0C3B1F"/>
                 </a:solidFill>
                 <a:latin typeface="Segoe UI"/>
               </a:rPr>
@@ -8031,7 +9245,7 @@
             <a:r>
               <a:rPr sz="2200" b="0">
                 <a:solidFill>
-                  <a:srgbClr val="1F2D33"/>
+                  <a:srgbClr val="0F1B14"/>
                 </a:solidFill>
                 <a:latin typeface="Segoe UI"/>
               </a:rPr>
@@ -8040,7 +9254,7 @@
             <a:r>
               <a:rPr sz="2200" b="1">
                 <a:solidFill>
-                  <a:srgbClr val="1B5E20"/>
+                  <a:srgbClr val="0C3B1F"/>
                 </a:solidFill>
                 <a:latin typeface="Segoe UI"/>
               </a:rPr>
@@ -8051,7 +9265,7 @@
       </p:sp>
       <p:sp>
         <p:nvSpPr>
-          <p:cNvPr id="6" name="Rounded Rectangle 5"/>
+          <p:cNvPr id="8" name="Rounded Rectangle 7"/>
           <p:cNvSpPr/>
           <p:nvPr/>
         </p:nvSpPr>
@@ -8064,12 +9278,10 @@
             <a:avLst/>
           </a:prstGeom>
           <a:solidFill>
-            <a:srgbClr val="E8F5E9"/>
+            <a:srgbClr val="0C3B1F"/>
           </a:solidFill>
           <a:ln>
-            <a:solidFill>
-              <a:srgbClr val="E8F5E9"/>
-            </a:solidFill>
+            <a:noFill/>
           </a:ln>
           <a:effectLst/>
         </p:spPr>
@@ -8088,19 +9300,63 @@
           </a:fontRef>
         </p:style>
         <p:txBody>
-          <a:bodyPr rtlCol="0" anchor="ctr" wrap="square" lIns="228600" rIns="228600"/>
+          <a:bodyPr rtlCol="0" anchor="ctr" wrap="square" lIns="292608" rIns="228600"/>
           <a:lstStyle/>
           <a:p>
             <a:pPr algn="ctr"/>
             <a:r>
               <a:rPr sz="1800" b="0">
                 <a:solidFill>
-                  <a:srgbClr val="1B5E20"/>
+                  <a:srgbClr val="F2FFE0"/>
                 </a:solidFill>
                 <a:latin typeface="Segoe UI"/>
               </a:rPr>
               <a:t>A projeção é só leitura: saldo, autorização e pagamento continuam decididos no serviço dono.</a:t>
             </a:r>
+          </a:p>
+        </p:txBody>
+      </p:sp>
+      <p:sp>
+        <p:nvSpPr>
+          <p:cNvPr id="9" name="Rectangle 8"/>
+          <p:cNvSpPr/>
+          <p:nvPr/>
+        </p:nvSpPr>
+        <p:spPr>
+          <a:xfrm>
+            <a:off x="685800" y="5532120"/>
+            <a:ext cx="100584" cy="868680"/>
+          </a:xfrm>
+          <a:prstGeom prst="rect">
+            <a:avLst/>
+          </a:prstGeom>
+          <a:solidFill>
+            <a:srgbClr val="A3E635"/>
+          </a:solidFill>
+          <a:ln>
+            <a:noFill/>
+          </a:ln>
+          <a:effectLst/>
+        </p:spPr>
+        <p:style>
+          <a:lnRef idx="1">
+            <a:schemeClr val="accent1"/>
+          </a:lnRef>
+          <a:fillRef idx="3">
+            <a:schemeClr val="accent1"/>
+          </a:fillRef>
+          <a:effectRef idx="2">
+            <a:schemeClr val="accent1"/>
+          </a:effectRef>
+          <a:fontRef idx="minor">
+            <a:schemeClr val="lt1"/>
+          </a:fontRef>
+        </p:style>
+        <p:txBody>
+          <a:bodyPr rtlCol="0" anchor="ctr"/>
+          <a:lstStyle/>
+          <a:p>
+            <a:pPr algn="ctr"/>
           </a:p>
         </p:txBody>
       </p:sp>

</xml_diff>